<commit_message>
ia NON PERMISE, code par toi même
</commit_message>
<xml_diff>
--- a/docs/582-511-web5/assets/documents/Web5_recit-defilant-lancement.pptx
+++ b/docs/582-511-web5/assets/documents/Web5_recit-defilant-lancement.pptx
@@ -26,9 +26,10 @@
     <p:sldId id="274" r:id="rId20"/>
     <p:sldId id="275" r:id="rId21"/>
     <p:sldId id="276" r:id="rId22"/>
+    <p:sldId id="277" r:id="rId23"/>
   </p:sldIdLst>
   <p:notesMasterIdLst>
-    <p:notesMasterId r:id="rId23"/>
+    <p:notesMasterId r:id="rId24"/>
   </p:notesMasterIdLst>
   <p:sldSz cx="12192000" cy="6858000"/>
   <p:notesSz cx="6858000" cy="12192000"/>
@@ -127,7 +128,7 @@
   <p:extLst>
     <p:ext uri="{521415D9-36F7-43E2-AB2F-B90AF26B5E84}">
       <p14:sectionLst xmlns:p14="http://schemas.microsoft.com/office/powerpoint/2010/main">
-        <p14:section name="Le projet" id="{863622ea-6e8e-da74-eff5-5c04fd50cca6}">
+        <p14:section name="Le projet" id="{37408c3e-cb90-cf10-2823-6d51edb6f835}">
           <p14:sldIdLst>
             <p14:sldId id="256"/>
             <p14:sldId id="257"/>
@@ -135,7 +136,7 @@
             <p14:sldId id="259"/>
           </p14:sldIdLst>
         </p14:section>
-        <p14:section name="Le produit" id="{dd24f22e-cfbd-8d6a-f15c-c53430bc200c}">
+        <p14:section name="Le produit" id="{537eca6a-df26-dfdb-4a72-67943e1a7666}">
           <p14:sldIdLst>
             <p14:sldId id="260"/>
             <p14:sldId id="261"/>
@@ -146,26 +147,27 @@
             <p14:sldId id="266"/>
           </p14:sldIdLst>
         </p14:section>
-        <p14:section name="Évaluation" id="{ed05218f-ea39-4b96-d50f-39b1e999ee10}">
+        <p14:section name="Évaluation" id="{c0a6f961-9075-33c4-0ffc-c0dd0c63ce8d}">
           <p14:sldIdLst>
             <p14:sldId id="267"/>
             <p14:sldId id="268"/>
             <p14:sldId id="269"/>
           </p14:sldIdLst>
         </p14:section>
-        <p14:section name="Calendrier" id="{41312cec-5e87-b20c-1e61-e3c4d5e56c19}">
+        <p14:section name="Calendrier" id="{4a371999-4bc9-1a7c-1e6c-b975a3f96467}">
           <p14:sldIdLst>
             <p14:sldId id="270"/>
             <p14:sldId id="271"/>
             <p14:sldId id="272"/>
+            <p14:sldId id="273"/>
           </p14:sldIdLst>
         </p14:section>
-        <p14:section name="À vous" id="{b2bef97d-a041-f01a-f916-3fa8f482e066}">
+        <p14:section name="À vous" id="{4f22876a-1a4a-8923-388a-ff18ce4c9853}">
           <p14:sldIdLst>
-            <p14:sldId id="273"/>
             <p14:sldId id="274"/>
             <p14:sldId id="275"/>
             <p14:sldId id="276"/>
+            <p14:sldId id="277"/>
           </p14:sldIdLst>
         </p14:section>
       </p14:sectionLst>
@@ -1276,7 +1278,7 @@
           <a:p>
             <a:r>
               <a:rPr lang="en-US" dirty="0"/>
-              <a:t>Je vais vous demander de me montrer votre projet à chaque étape. Si je sens qu'une étape a été sautée, par exemple un chapitre complet généré sans storyboard ni compréhension, je vais vous demander de la recommencer. Et ce sera la même règle pour tout le monde. L'IA reste permise, aux mêmes conditions qu'au portfolio : documentée dans le journal, et comprise. Ça se verra à la défense.</a:t>
+              <a:t>Je vais vous demander de me montrer votre projet à chaque étape. Si je sens qu'une étape a été sautée, par exemple un chapitre complet généré sans storyboard ni compréhension, je vais vous demander de la recommencer. Et ce sera la même règle pour tout le monde. Ça se verra à la défense.</a:t>
             </a:r>
             <a:endParaRPr lang="en-US" dirty="0"/>
           </a:p>
@@ -1364,7 +1366,7 @@
           <a:p>
             <a:r>
               <a:rPr lang="en-US" dirty="0"/>
-              <a:t>Tout est dans la page des consignes et le gabarit du cahier de charges. Suivez l'ordre : le contenu d'abord, les animations ensuite, la matrice ensemble. Le mercredi 21 octobre, arrivez avec votre concept et vos chapitres : on avance ensemble le storyboard et la matrice.</a:t>
+              <a:t>Au portfolio, l'IA était permise, documentée et comprise. Cette fois, on fait un essai : je veux que vous soyez capables de coder par vous-mêmes, et que demander à l'IA ne soit pas un réflexe. Pas de Copilot, pas de ChatGPT ou Claude pour le code, pas d'IA pour le cahier de charges ni le storyboard. Seule exception : générer une image source pour votre média animable, que vous préparez ensuite vous-même. Vous avez la documentation, les notes, la démo, vos collègues et moi. C'est jusqu'à nouvel ordre : si ça change, je vous le dirai.</a:t>
             </a:r>
             <a:endParaRPr lang="en-US" dirty="0"/>
           </a:p>
@@ -1452,7 +1454,7 @@
           <a:p>
             <a:r>
               <a:rPr lang="en-US" dirty="0"/>
-              <a:t>GSAP, le CSS au défilement et Vue arrivent en classe à partir du 28 octobre. Bien planifier maintenant, c'est coder plus vite ensuite.</a:t>
+              <a:t>Tout est dans la page des consignes et le gabarit du cahier de charges. Suivez l'ordre : le contenu d'abord, les animations ensuite, la matrice ensemble. Le mercredi 21 octobre, arrivez avec votre concept et vos chapitres : on avance ensemble le storyboard et la matrice.</a:t>
             </a:r>
             <a:endParaRPr lang="en-US" dirty="0"/>
           </a:p>
@@ -1628,7 +1630,7 @@
           <a:p>
             <a:r>
               <a:rPr lang="en-US" dirty="0"/>
-              <a:t>C'est la remise 1, 5 % de la note, en équipe, déposée le vendredi 23 au plus tard à 23 h 59. Le mercredi 21, vous me présentez votre avancement en classe. Je fais la rétroaction le 28, et vous commencez à coder.</a:t>
+              <a:t>GSAP, le CSS au défilement et Vue arrivent en classe à partir du 28 octobre. Bien planifier maintenant, c'est coder plus vite ensuite.</a:t>
             </a:r>
             <a:endParaRPr lang="en-US" dirty="0"/>
           </a:p>
@@ -1716,7 +1718,7 @@
           <a:p>
             <a:r>
               <a:rPr lang="en-US" dirty="0"/>
-              <a:t>Gr. Enric : votre jury de portfolio est jeudi prochain. Gardez-le en priorité, mais lancez au moins le thème et le dépôt aujourd'hui.</a:t>
+              <a:t>C'est la remise 1, 5 % de la note, en équipe, déposée le vendredi 23 au plus tard à 23 h 59. Le mercredi 21, vous me présentez votre avancement en classe. Je fais la rétroaction le 28, et vous commencez à coder.</a:t>
             </a:r>
             <a:endParaRPr lang="en-US" dirty="0"/>
           </a:p>
@@ -1740,6 +1742,94 @@
             <a:fld id="{F7021451-1387-4CA6-816F-3879F97B5CBC}" type="slidenum">
               <a:rPr lang="en-US"/>
               <a:t>21</a:t>
+            </a:fld>
+            <a:endParaRPr lang="en-US"/>
+          </a:p>
+        </p:txBody>
+      </p:sp>
+    </p:spTree>
+    <p:extLst>
+      <p:ext uri="{BB962C8B-B14F-4D97-AF65-F5344CB8AC3E}">
+        <p14:creationId xmlns:p14="http://schemas.microsoft.com/office/powerpoint/2010/main" val="1024086991"/>
+      </p:ext>
+    </p:extLst>
+  </p:cSld>
+  <p:clrMapOvr>
+    <a:masterClrMapping/>
+  </p:clrMapOvr>
+</p:notes>
+</file>
+
+<file path=ppt/notesSlides/notesSlide22.xml><?xml version="1.0" encoding="utf-8"?>
+<p:notes xmlns:a="http://schemas.openxmlformats.org/drawingml/2006/main" xmlns:r="http://schemas.openxmlformats.org/officeDocument/2006/relationships" xmlns:p="http://schemas.openxmlformats.org/presentationml/2006/main">
+  <p:cSld>
+    <p:spTree>
+      <p:nvGrpSpPr>
+        <p:cNvPr id="1" name=""/>
+        <p:cNvGrpSpPr/>
+        <p:nvPr/>
+      </p:nvGrpSpPr>
+      <p:grpSpPr>
+        <a:xfrm>
+          <a:off x="0" y="0"/>
+          <a:ext cx="0" cy="0"/>
+          <a:chOff x="0" y="0"/>
+          <a:chExt cx="0" cy="0"/>
+        </a:xfrm>
+      </p:grpSpPr>
+      <p:sp>
+        <p:nvSpPr>
+          <p:cNvPr id="2" name="Slide Image Placeholder 1"/>
+          <p:cNvSpPr>
+            <a:spLocks noGrp="1" noRot="1" noChangeAspect="1"/>
+          </p:cNvSpPr>
+          <p:nvPr>
+            <p:ph type="sldImg"/>
+          </p:nvPr>
+        </p:nvSpPr>
+        <p:spPr/>
+      </p:sp>
+      <p:sp>
+        <p:nvSpPr>
+          <p:cNvPr id="3" name="Notes Placeholder 2"/>
+          <p:cNvSpPr>
+            <a:spLocks noGrp="1"/>
+          </p:cNvSpPr>
+          <p:nvPr>
+            <p:ph type="body" idx="1"/>
+          </p:nvPr>
+        </p:nvSpPr>
+        <p:spPr/>
+        <p:txBody>
+          <a:bodyPr/>
+          <a:lstStyle/>
+          <a:p>
+            <a:r>
+              <a:rPr lang="en-US" dirty="0"/>
+              <a:t>Gr. Enric : votre jury de portfolio est jeudi prochain. Gardez-le en priorité, mais lancez au moins le thème et le dépôt aujourd'hui.</a:t>
+            </a:r>
+            <a:endParaRPr lang="en-US" dirty="0"/>
+          </a:p>
+        </p:txBody>
+      </p:sp>
+      <p:sp>
+        <p:nvSpPr>
+          <p:cNvPr id="4" name="Slide Number Placeholder 3"/>
+          <p:cNvSpPr>
+            <a:spLocks noGrp="1"/>
+          </p:cNvSpPr>
+          <p:nvPr>
+            <p:ph type="sldNum" sz="quarter" idx="10"/>
+          </p:nvPr>
+        </p:nvSpPr>
+        <p:spPr/>
+        <p:txBody>
+          <a:bodyPr/>
+          <a:lstStyle/>
+          <a:p>
+            <a:fld id="{F7021451-1387-4CA6-816F-3879F97B5CBC}" type="slidenum">
+              <a:rPr lang="en-US"/>
+              <a:t>22</a:t>
             </a:fld>
             <a:endParaRPr lang="en-US"/>
           </a:p>
@@ -5429,7 +5519,7 @@
                   <a:schemeClr val="tx2"/>
                 </a:solidFill>
               </a:rPr>
-              <a:t>Un par personne, avec vos usages de l'IA</a:t>
+              <a:t>Un par personne, à chaque bloc</a:t>
             </a:r>
             <a:endParaRPr lang="en-US" sz="1400" dirty="0"/>
           </a:p>
@@ -7516,7 +7606,7 @@
                   <a:schemeClr val="tx2"/>
                 </a:solidFill>
               </a:rPr>
-              <a:t>L'IA : permise, documentée, comprise.</a:t>
+              <a:t>L'IA : pour vos médias seulement.</a:t>
             </a:r>
             <a:endParaRPr lang="en-US" sz="2200" dirty="0"/>
           </a:p>
@@ -7602,8 +7692,8 @@
         </p:nvSpPr>
         <p:spPr>
           <a:xfrm>
-            <a:off x="731520" y="411480"/>
-            <a:ext cx="10698480" cy="822960"/>
+            <a:off x="731520" y="1828800"/>
+            <a:ext cx="10698480" cy="2377440"/>
           </a:xfrm>
           <a:prstGeom prst="rect">
             <a:avLst/>
@@ -7619,88 +7709,49 @@
               <a:buNone/>
             </a:pPr>
             <a:r>
-              <a:rPr lang="en-US" sz="3200" b="1" dirty="0">
+              <a:rPr lang="en-US" sz="6000" b="1" dirty="0">
                 <a:solidFill>
                   <a:schemeClr val="tx1"/>
                 </a:solidFill>
               </a:rPr>
-              <a:t>Vos deux prochaines semaines</a:t>
-            </a:r>
-            <a:endParaRPr lang="en-US" sz="3200" dirty="0"/>
-          </a:p>
-        </p:txBody>
-      </p:sp>
-      <p:sp>
-        <p:nvSpPr>
-          <p:cNvPr id="3" name="etape-0"/>
-          <p:cNvSpPr/>
-          <p:nvPr/>
-        </p:nvSpPr>
-        <p:spPr>
-          <a:xfrm>
-            <a:off x="731520" y="1508760"/>
-            <a:ext cx="566928" cy="566928"/>
-          </a:xfrm>
-          <a:prstGeom prst="ellipse">
-            <a:avLst/>
-          </a:prstGeom>
-          <a:solidFill>
-            <a:schemeClr val="accent1"/>
-          </a:solidFill>
-          <a:ln w="12700">
-            <a:solidFill>
-              <a:schemeClr val="accent1"/>
-            </a:solidFill>
-            <a:prstDash val="solid"/>
-          </a:ln>
-        </p:spPr>
-      </p:sp>
-      <p:sp>
-        <p:nvSpPr>
-          <p:cNvPr id="4" name="Text 2"/>
-          <p:cNvSpPr txBox="1"/>
-          <p:nvPr/>
-        </p:nvSpPr>
-        <p:spPr>
-          <a:xfrm>
-            <a:off x="731520" y="1508760"/>
-            <a:ext cx="566928" cy="566928"/>
-          </a:xfrm>
-          <a:prstGeom prst="rect">
-            <a:avLst/>
-          </a:prstGeom>
-          <a:noFill/>
-          <a:ln/>
-        </p:spPr>
-        <p:txBody>
-          <a:bodyPr wrap="square" lIns="0" tIns="0" rIns="0" bIns="0" rtlCol="0" anchor="ctr"/>
-          <a:lstStyle/>
-          <a:p>
-            <a:pPr algn="ctr" indent="0" marL="0">
-              <a:buNone/>
-            </a:pPr>
-            <a:r>
-              <a:rPr lang="en-US" sz="2000" b="1" dirty="0">
-                <a:solidFill>
-                  <a:schemeClr val="bg1"/>
-                </a:solidFill>
-              </a:rPr>
-              <a:t>1</a:t>
-            </a:r>
-            <a:endParaRPr lang="en-US" sz="2000" dirty="0"/>
-          </a:p>
-        </p:txBody>
-      </p:sp>
-      <p:sp>
-        <p:nvSpPr>
-          <p:cNvPr id="5" name="Text 3"/>
-          <p:cNvSpPr txBox="1"/>
-          <p:nvPr/>
-        </p:nvSpPr>
-        <p:spPr>
-          <a:xfrm>
-            <a:off x="1508760" y="1472184"/>
-            <a:ext cx="9875520" cy="365760"/>
+              <a:t>Cette fois, vous codez </a:t>
+            </a:r>
+            <a:pPr algn="l" indent="0" marL="0">
+              <a:buNone/>
+            </a:pPr>
+            <a:r>
+              <a:rPr lang="en-US" sz="6000" b="1" dirty="0">
+                <a:solidFill>
+                  <a:schemeClr val="accent1"/>
+                </a:solidFill>
+              </a:rPr>
+              <a:t>sans IA</a:t>
+            </a:r>
+            <a:pPr algn="l" indent="0" marL="0">
+              <a:buNone/>
+            </a:pPr>
+            <a:r>
+              <a:rPr lang="en-US" sz="6000" b="1" dirty="0">
+                <a:solidFill>
+                  <a:schemeClr val="tx1"/>
+                </a:solidFill>
+              </a:rPr>
+              <a:t>.</a:t>
+            </a:r>
+            <a:endParaRPr lang="en-US" sz="6000" dirty="0"/>
+          </a:p>
+        </p:txBody>
+      </p:sp>
+      <p:sp>
+        <p:nvSpPr>
+          <p:cNvPr id="3" name="kicker"/>
+          <p:cNvSpPr txBox="1"/>
+          <p:nvPr/>
+        </p:nvSpPr>
+        <p:spPr>
+          <a:xfrm>
+            <a:off x="731520" y="1463040"/>
+            <a:ext cx="10698480" cy="365760"/>
           </a:xfrm>
           <a:prstGeom prst="rect">
             <a:avLst/>
@@ -7716,715 +7767,14 @@
               <a:buNone/>
             </a:pPr>
             <a:r>
-              <a:rPr lang="en-US" sz="2000" b="1" dirty="0">
-                <a:solidFill>
-                  <a:schemeClr val="tx1"/>
-                </a:solidFill>
-              </a:rPr>
-              <a:t>Le concept et les chapitres</a:t>
-            </a:r>
-            <a:endParaRPr lang="en-US" sz="2000" dirty="0"/>
-          </a:p>
-        </p:txBody>
-      </p:sp>
-      <p:sp>
-        <p:nvSpPr>
-          <p:cNvPr id="6" name="Text 4"/>
-          <p:cNvSpPr txBox="1"/>
-          <p:nvPr/>
-        </p:nvSpPr>
-        <p:spPr>
-          <a:xfrm>
-            <a:off x="1508760" y="1819656"/>
-            <a:ext cx="9875520" cy="292608"/>
-          </a:xfrm>
-          <a:prstGeom prst="rect">
-            <a:avLst/>
-          </a:prstGeom>
-          <a:noFill/>
-          <a:ln/>
-        </p:spPr>
-        <p:txBody>
-          <a:bodyPr wrap="square" lIns="0" tIns="0" rIns="0" bIns="0" rtlCol="0" anchor="ctr"/>
-          <a:lstStyle/>
-          <a:p>
-            <a:pPr indent="0" marL="0">
-              <a:buNone/>
-            </a:pPr>
-            <a:r>
-              <a:rPr lang="en-US" sz="1400" dirty="0">
+              <a:rPr lang="en-US" sz="1300" spc="400" kern="0" dirty="0">
                 <a:solidFill>
                   <a:schemeClr val="tx2"/>
                 </a:solidFill>
               </a:rPr>
-              <a:t>Ce que chaque chapitre raconte</a:t>
-            </a:r>
-            <a:endParaRPr lang="en-US" sz="1400" dirty="0"/>
-          </a:p>
-        </p:txBody>
-      </p:sp>
-      <p:sp>
-        <p:nvSpPr>
-          <p:cNvPr id="7" name="etape-1"/>
-          <p:cNvSpPr/>
-          <p:nvPr/>
-        </p:nvSpPr>
-        <p:spPr>
-          <a:xfrm>
-            <a:off x="731520" y="2286000"/>
-            <a:ext cx="566928" cy="566928"/>
-          </a:xfrm>
-          <a:prstGeom prst="ellipse">
-            <a:avLst/>
-          </a:prstGeom>
-          <a:solidFill>
-            <a:schemeClr val="accent1"/>
-          </a:solidFill>
-          <a:ln w="12700">
-            <a:solidFill>
-              <a:schemeClr val="accent1"/>
-            </a:solidFill>
-            <a:prstDash val="solid"/>
-          </a:ln>
-        </p:spPr>
-      </p:sp>
-      <p:sp>
-        <p:nvSpPr>
-          <p:cNvPr id="8" name="Text 6"/>
-          <p:cNvSpPr txBox="1"/>
-          <p:nvPr/>
-        </p:nvSpPr>
-        <p:spPr>
-          <a:xfrm>
-            <a:off x="731520" y="2286000"/>
-            <a:ext cx="566928" cy="566928"/>
-          </a:xfrm>
-          <a:prstGeom prst="rect">
-            <a:avLst/>
-          </a:prstGeom>
-          <a:noFill/>
-          <a:ln/>
-        </p:spPr>
-        <p:txBody>
-          <a:bodyPr wrap="square" lIns="0" tIns="0" rIns="0" bIns="0" rtlCol="0" anchor="ctr"/>
-          <a:lstStyle/>
-          <a:p>
-            <a:pPr algn="ctr" indent="0" marL="0">
-              <a:buNone/>
-            </a:pPr>
-            <a:r>
-              <a:rPr lang="en-US" sz="2000" b="1" dirty="0">
-                <a:solidFill>
-                  <a:schemeClr val="bg1"/>
-                </a:solidFill>
-              </a:rPr>
-              <a:t>2</a:t>
-            </a:r>
-            <a:endParaRPr lang="en-US" sz="2000" dirty="0"/>
-          </a:p>
-        </p:txBody>
-      </p:sp>
-      <p:sp>
-        <p:nvSpPr>
-          <p:cNvPr id="9" name="Text 7"/>
-          <p:cNvSpPr txBox="1"/>
-          <p:nvPr/>
-        </p:nvSpPr>
-        <p:spPr>
-          <a:xfrm>
-            <a:off x="1508760" y="2249424"/>
-            <a:ext cx="9875520" cy="365760"/>
-          </a:xfrm>
-          <a:prstGeom prst="rect">
-            <a:avLst/>
-          </a:prstGeom>
-          <a:noFill/>
-          <a:ln/>
-        </p:spPr>
-        <p:txBody>
-          <a:bodyPr wrap="square" lIns="0" tIns="0" rIns="0" bIns="0" rtlCol="0" anchor="ctr"/>
-          <a:lstStyle/>
-          <a:p>
-            <a:pPr indent="0" marL="0">
-              <a:buNone/>
-            </a:pPr>
-            <a:r>
-              <a:rPr lang="en-US" sz="2000" b="1" dirty="0">
-                <a:solidFill>
-                  <a:schemeClr val="tx1"/>
-                </a:solidFill>
-              </a:rPr>
-              <a:t>Le storyboard dans Figma</a:t>
-            </a:r>
-            <a:endParaRPr lang="en-US" sz="2000" dirty="0"/>
-          </a:p>
-        </p:txBody>
-      </p:sp>
-      <p:sp>
-        <p:nvSpPr>
-          <p:cNvPr id="10" name="Text 8"/>
-          <p:cNvSpPr txBox="1"/>
-          <p:nvPr/>
-        </p:nvSpPr>
-        <p:spPr>
-          <a:xfrm>
-            <a:off x="1508760" y="2596896"/>
-            <a:ext cx="9875520" cy="292608"/>
-          </a:xfrm>
-          <a:prstGeom prst="rect">
-            <a:avLst/>
-          </a:prstGeom>
-          <a:noFill/>
-          <a:ln/>
-        </p:spPr>
-        <p:txBody>
-          <a:bodyPr wrap="square" lIns="0" tIns="0" rIns="0" bIns="0" rtlCol="0" anchor="ctr"/>
-          <a:lstStyle/>
-          <a:p>
-            <a:pPr indent="0" marL="0">
-              <a:buNone/>
-            </a:pPr>
-            <a:r>
-              <a:rPr lang="en-US" sz="1400" dirty="0">
-                <a:solidFill>
-                  <a:schemeClr val="tx2"/>
-                </a:solidFill>
-              </a:rPr>
-              <a:t>Un cadre par chapitre, annoté</a:t>
-            </a:r>
-            <a:endParaRPr lang="en-US" sz="1400" dirty="0"/>
-          </a:p>
-        </p:txBody>
-      </p:sp>
-      <p:sp>
-        <p:nvSpPr>
-          <p:cNvPr id="11" name="etape-2"/>
-          <p:cNvSpPr/>
-          <p:nvPr/>
-        </p:nvSpPr>
-        <p:spPr>
-          <a:xfrm>
-            <a:off x="731520" y="3063240"/>
-            <a:ext cx="566928" cy="566928"/>
-          </a:xfrm>
-          <a:prstGeom prst="ellipse">
-            <a:avLst/>
-          </a:prstGeom>
-          <a:solidFill>
-            <a:schemeClr val="accent1"/>
-          </a:solidFill>
-          <a:ln w="12700">
-            <a:solidFill>
-              <a:schemeClr val="accent1"/>
-            </a:solidFill>
-            <a:prstDash val="solid"/>
-          </a:ln>
-        </p:spPr>
-      </p:sp>
-      <p:sp>
-        <p:nvSpPr>
-          <p:cNvPr id="12" name="Text 10"/>
-          <p:cNvSpPr txBox="1"/>
-          <p:nvPr/>
-        </p:nvSpPr>
-        <p:spPr>
-          <a:xfrm>
-            <a:off x="731520" y="3063240"/>
-            <a:ext cx="566928" cy="566928"/>
-          </a:xfrm>
-          <a:prstGeom prst="rect">
-            <a:avLst/>
-          </a:prstGeom>
-          <a:noFill/>
-          <a:ln/>
-        </p:spPr>
-        <p:txBody>
-          <a:bodyPr wrap="square" lIns="0" tIns="0" rIns="0" bIns="0" rtlCol="0" anchor="ctr"/>
-          <a:lstStyle/>
-          <a:p>
-            <a:pPr algn="ctr" indent="0" marL="0">
-              <a:buNone/>
-            </a:pPr>
-            <a:r>
-              <a:rPr lang="en-US" sz="2000" b="1" dirty="0">
-                <a:solidFill>
-                  <a:schemeClr val="bg1"/>
-                </a:solidFill>
-              </a:rPr>
-              <a:t>3</a:t>
-            </a:r>
-            <a:endParaRPr lang="en-US" sz="2000" dirty="0"/>
-          </a:p>
-        </p:txBody>
-      </p:sp>
-      <p:sp>
-        <p:nvSpPr>
-          <p:cNvPr id="13" name="Text 11"/>
-          <p:cNvSpPr txBox="1"/>
-          <p:nvPr/>
-        </p:nvSpPr>
-        <p:spPr>
-          <a:xfrm>
-            <a:off x="1508760" y="3026664"/>
-            <a:ext cx="9875520" cy="365760"/>
-          </a:xfrm>
-          <a:prstGeom prst="rect">
-            <a:avLst/>
-          </a:prstGeom>
-          <a:noFill/>
-          <a:ln/>
-        </p:spPr>
-        <p:txBody>
-          <a:bodyPr wrap="square" lIns="0" tIns="0" rIns="0" bIns="0" rtlCol="0" anchor="ctr"/>
-          <a:lstStyle/>
-          <a:p>
-            <a:pPr indent="0" marL="0">
-              <a:buNone/>
-            </a:pPr>
-            <a:r>
-              <a:rPr lang="en-US" sz="2000" b="1" dirty="0">
-                <a:solidFill>
-                  <a:schemeClr val="tx1"/>
-                </a:solidFill>
-              </a:rPr>
-              <a:t>La matrice de responsabilités</a:t>
-            </a:r>
-            <a:endParaRPr lang="en-US" sz="2000" dirty="0"/>
-          </a:p>
-        </p:txBody>
-      </p:sp>
-      <p:sp>
-        <p:nvSpPr>
-          <p:cNvPr id="14" name="Text 12"/>
-          <p:cNvSpPr txBox="1"/>
-          <p:nvPr/>
-        </p:nvSpPr>
-        <p:spPr>
-          <a:xfrm>
-            <a:off x="1508760" y="3374136"/>
-            <a:ext cx="9875520" cy="292608"/>
-          </a:xfrm>
-          <a:prstGeom prst="rect">
-            <a:avLst/>
-          </a:prstGeom>
-          <a:noFill/>
-          <a:ln/>
-        </p:spPr>
-        <p:txBody>
-          <a:bodyPr wrap="square" lIns="0" tIns="0" rIns="0" bIns="0" rtlCol="0" anchor="ctr"/>
-          <a:lstStyle/>
-          <a:p>
-            <a:pPr indent="0" marL="0">
-              <a:buNone/>
-            </a:pPr>
-            <a:r>
-              <a:rPr lang="en-US" sz="1400" dirty="0">
-                <a:solidFill>
-                  <a:schemeClr val="tx2"/>
-                </a:solidFill>
-              </a:rPr>
-              <a:t>Qui possède quoi, ensemble</a:t>
-            </a:r>
-            <a:endParaRPr lang="en-US" sz="1400" dirty="0"/>
-          </a:p>
-        </p:txBody>
-      </p:sp>
-      <p:sp>
-        <p:nvSpPr>
-          <p:cNvPr id="15" name="etape-3"/>
-          <p:cNvSpPr/>
-          <p:nvPr/>
-        </p:nvSpPr>
-        <p:spPr>
-          <a:xfrm>
-            <a:off x="731520" y="3840480"/>
-            <a:ext cx="566928" cy="566928"/>
-          </a:xfrm>
-          <a:prstGeom prst="ellipse">
-            <a:avLst/>
-          </a:prstGeom>
-          <a:solidFill>
-            <a:schemeClr val="accent1"/>
-          </a:solidFill>
-          <a:ln w="12700">
-            <a:solidFill>
-              <a:schemeClr val="accent1"/>
-            </a:solidFill>
-            <a:prstDash val="solid"/>
-          </a:ln>
-        </p:spPr>
-      </p:sp>
-      <p:sp>
-        <p:nvSpPr>
-          <p:cNvPr id="16" name="Text 14"/>
-          <p:cNvSpPr txBox="1"/>
-          <p:nvPr/>
-        </p:nvSpPr>
-        <p:spPr>
-          <a:xfrm>
-            <a:off x="731520" y="3840480"/>
-            <a:ext cx="566928" cy="566928"/>
-          </a:xfrm>
-          <a:prstGeom prst="rect">
-            <a:avLst/>
-          </a:prstGeom>
-          <a:noFill/>
-          <a:ln/>
-        </p:spPr>
-        <p:txBody>
-          <a:bodyPr wrap="square" lIns="0" tIns="0" rIns="0" bIns="0" rtlCol="0" anchor="ctr"/>
-          <a:lstStyle/>
-          <a:p>
-            <a:pPr algn="ctr" indent="0" marL="0">
-              <a:buNone/>
-            </a:pPr>
-            <a:r>
-              <a:rPr lang="en-US" sz="2000" b="1" dirty="0">
-                <a:solidFill>
-                  <a:schemeClr val="bg1"/>
-                </a:solidFill>
-              </a:rPr>
-              <a:t>4</a:t>
-            </a:r>
-            <a:endParaRPr lang="en-US" sz="2000" dirty="0"/>
-          </a:p>
-        </p:txBody>
-      </p:sp>
-      <p:sp>
-        <p:nvSpPr>
-          <p:cNvPr id="17" name="Text 15"/>
-          <p:cNvSpPr txBox="1"/>
-          <p:nvPr/>
-        </p:nvSpPr>
-        <p:spPr>
-          <a:xfrm>
-            <a:off x="1508760" y="3803904"/>
-            <a:ext cx="9875520" cy="365760"/>
-          </a:xfrm>
-          <a:prstGeom prst="rect">
-            <a:avLst/>
-          </a:prstGeom>
-          <a:noFill/>
-          <a:ln/>
-        </p:spPr>
-        <p:txBody>
-          <a:bodyPr wrap="square" lIns="0" tIns="0" rIns="0" bIns="0" rtlCol="0" anchor="ctr"/>
-          <a:lstStyle/>
-          <a:p>
-            <a:pPr indent="0" marL="0">
-              <a:buNone/>
-            </a:pPr>
-            <a:r>
-              <a:rPr lang="en-US" sz="2000" b="1" dirty="0">
-                <a:solidFill>
-                  <a:schemeClr val="tx1"/>
-                </a:solidFill>
-              </a:rPr>
-              <a:t>Votre média animable</a:t>
-            </a:r>
-            <a:endParaRPr lang="en-US" sz="2000" dirty="0"/>
-          </a:p>
-        </p:txBody>
-      </p:sp>
-      <p:sp>
-        <p:nvSpPr>
-          <p:cNvPr id="18" name="Text 16"/>
-          <p:cNvSpPr txBox="1"/>
-          <p:nvPr/>
-        </p:nvSpPr>
-        <p:spPr>
-          <a:xfrm>
-            <a:off x="1508760" y="4151376"/>
-            <a:ext cx="9875520" cy="292608"/>
-          </a:xfrm>
-          <a:prstGeom prst="rect">
-            <a:avLst/>
-          </a:prstGeom>
-          <a:noFill/>
-          <a:ln/>
-        </p:spPr>
-        <p:txBody>
-          <a:bodyPr wrap="square" lIns="0" tIns="0" rIns="0" bIns="0" rtlCol="0" anchor="ctr"/>
-          <a:lstStyle/>
-          <a:p>
-            <a:pPr indent="0" marL="0">
-              <a:buNone/>
-            </a:pPr>
-            <a:r>
-              <a:rPr lang="en-US" sz="1400" dirty="0">
-                <a:solidFill>
-                  <a:schemeClr val="tx2"/>
-                </a:solidFill>
-              </a:rPr>
-              <a:t>Calques, spritesheet ou SVG</a:t>
-            </a:r>
-            <a:endParaRPr lang="en-US" sz="1400" dirty="0"/>
-          </a:p>
-        </p:txBody>
-      </p:sp>
-      <p:sp>
-        <p:nvSpPr>
-          <p:cNvPr id="19" name="etape-4"/>
-          <p:cNvSpPr/>
-          <p:nvPr/>
-        </p:nvSpPr>
-        <p:spPr>
-          <a:xfrm>
-            <a:off x="731520" y="4617720"/>
-            <a:ext cx="566928" cy="566928"/>
-          </a:xfrm>
-          <a:prstGeom prst="ellipse">
-            <a:avLst/>
-          </a:prstGeom>
-          <a:solidFill>
-            <a:schemeClr val="accent1"/>
-          </a:solidFill>
-          <a:ln w="12700">
-            <a:solidFill>
-              <a:schemeClr val="accent1"/>
-            </a:solidFill>
-            <a:prstDash val="solid"/>
-          </a:ln>
-        </p:spPr>
-      </p:sp>
-      <p:sp>
-        <p:nvSpPr>
-          <p:cNvPr id="20" name="Text 18"/>
-          <p:cNvSpPr txBox="1"/>
-          <p:nvPr/>
-        </p:nvSpPr>
-        <p:spPr>
-          <a:xfrm>
-            <a:off x="731520" y="4617720"/>
-            <a:ext cx="566928" cy="566928"/>
-          </a:xfrm>
-          <a:prstGeom prst="rect">
-            <a:avLst/>
-          </a:prstGeom>
-          <a:noFill/>
-          <a:ln/>
-        </p:spPr>
-        <p:txBody>
-          <a:bodyPr wrap="square" lIns="0" tIns="0" rIns="0" bIns="0" rtlCol="0" anchor="ctr"/>
-          <a:lstStyle/>
-          <a:p>
-            <a:pPr algn="ctr" indent="0" marL="0">
-              <a:buNone/>
-            </a:pPr>
-            <a:r>
-              <a:rPr lang="en-US" sz="2000" b="1" dirty="0">
-                <a:solidFill>
-                  <a:schemeClr val="bg1"/>
-                </a:solidFill>
-              </a:rPr>
-              <a:t>5</a:t>
-            </a:r>
-            <a:endParaRPr lang="en-US" sz="2000" dirty="0"/>
-          </a:p>
-        </p:txBody>
-      </p:sp>
-      <p:sp>
-        <p:nvSpPr>
-          <p:cNvPr id="21" name="Text 19"/>
-          <p:cNvSpPr txBox="1"/>
-          <p:nvPr/>
-        </p:nvSpPr>
-        <p:spPr>
-          <a:xfrm>
-            <a:off x="1508760" y="4581144"/>
-            <a:ext cx="9875520" cy="365760"/>
-          </a:xfrm>
-          <a:prstGeom prst="rect">
-            <a:avLst/>
-          </a:prstGeom>
-          <a:noFill/>
-          <a:ln/>
-        </p:spPr>
-        <p:txBody>
-          <a:bodyPr wrap="square" lIns="0" tIns="0" rIns="0" bIns="0" rtlCol="0" anchor="ctr"/>
-          <a:lstStyle/>
-          <a:p>
-            <a:pPr indent="0" marL="0">
-              <a:buNone/>
-            </a:pPr>
-            <a:r>
-              <a:rPr lang="en-US" sz="2000" b="1" dirty="0">
-                <a:solidFill>
-                  <a:schemeClr val="tx1"/>
-                </a:solidFill>
-              </a:rPr>
-              <a:t>Le moment dataviz</a:t>
-            </a:r>
-            <a:endParaRPr lang="en-US" sz="2000" dirty="0"/>
-          </a:p>
-        </p:txBody>
-      </p:sp>
-      <p:sp>
-        <p:nvSpPr>
-          <p:cNvPr id="22" name="Text 20"/>
-          <p:cNvSpPr txBox="1"/>
-          <p:nvPr/>
-        </p:nvSpPr>
-        <p:spPr>
-          <a:xfrm>
-            <a:off x="1508760" y="4928616"/>
-            <a:ext cx="9875520" cy="292608"/>
-          </a:xfrm>
-          <a:prstGeom prst="rect">
-            <a:avLst/>
-          </a:prstGeom>
-          <a:noFill/>
-          <a:ln/>
-        </p:spPr>
-        <p:txBody>
-          <a:bodyPr wrap="square" lIns="0" tIns="0" rIns="0" bIns="0" rtlCol="0" anchor="ctr"/>
-          <a:lstStyle/>
-          <a:p>
-            <a:pPr indent="0" marL="0">
-              <a:buNone/>
-            </a:pPr>
-            <a:r>
-              <a:rPr lang="en-US" sz="1400" dirty="0">
-                <a:solidFill>
-                  <a:schemeClr val="tx2"/>
-                </a:solidFill>
-              </a:rPr>
-              <a:t>L'idée et le genre de données</a:t>
-            </a:r>
-            <a:endParaRPr lang="en-US" sz="1400" dirty="0"/>
-          </a:p>
-        </p:txBody>
-      </p:sp>
-      <p:sp>
-        <p:nvSpPr>
-          <p:cNvPr id="23" name="etape-5"/>
-          <p:cNvSpPr/>
-          <p:nvPr/>
-        </p:nvSpPr>
-        <p:spPr>
-          <a:xfrm>
-            <a:off x="731520" y="5394960"/>
-            <a:ext cx="566928" cy="566928"/>
-          </a:xfrm>
-          <a:prstGeom prst="ellipse">
-            <a:avLst/>
-          </a:prstGeom>
-          <a:solidFill>
-            <a:schemeClr val="accent1"/>
-          </a:solidFill>
-          <a:ln w="12700">
-            <a:solidFill>
-              <a:schemeClr val="accent1"/>
-            </a:solidFill>
-            <a:prstDash val="solid"/>
-          </a:ln>
-        </p:spPr>
-      </p:sp>
-      <p:sp>
-        <p:nvSpPr>
-          <p:cNvPr id="24" name="Text 22"/>
-          <p:cNvSpPr txBox="1"/>
-          <p:nvPr/>
-        </p:nvSpPr>
-        <p:spPr>
-          <a:xfrm>
-            <a:off x="731520" y="5394960"/>
-            <a:ext cx="566928" cy="566928"/>
-          </a:xfrm>
-          <a:prstGeom prst="rect">
-            <a:avLst/>
-          </a:prstGeom>
-          <a:noFill/>
-          <a:ln/>
-        </p:spPr>
-        <p:txBody>
-          <a:bodyPr wrap="square" lIns="0" tIns="0" rIns="0" bIns="0" rtlCol="0" anchor="ctr"/>
-          <a:lstStyle/>
-          <a:p>
-            <a:pPr algn="ctr" indent="0" marL="0">
-              <a:buNone/>
-            </a:pPr>
-            <a:r>
-              <a:rPr lang="en-US" sz="2000" b="1" dirty="0">
-                <a:solidFill>
-                  <a:schemeClr val="bg1"/>
-                </a:solidFill>
-              </a:rPr>
-              <a:t>6</a:t>
-            </a:r>
-            <a:endParaRPr lang="en-US" sz="2000" dirty="0"/>
-          </a:p>
-        </p:txBody>
-      </p:sp>
-      <p:sp>
-        <p:nvSpPr>
-          <p:cNvPr id="25" name="Text 23"/>
-          <p:cNvSpPr txBox="1"/>
-          <p:nvPr/>
-        </p:nvSpPr>
-        <p:spPr>
-          <a:xfrm>
-            <a:off x="1508760" y="5358384"/>
-            <a:ext cx="9875520" cy="365760"/>
-          </a:xfrm>
-          <a:prstGeom prst="rect">
-            <a:avLst/>
-          </a:prstGeom>
-          <a:noFill/>
-          <a:ln/>
-        </p:spPr>
-        <p:txBody>
-          <a:bodyPr wrap="square" lIns="0" tIns="0" rIns="0" bIns="0" rtlCol="0" anchor="ctr"/>
-          <a:lstStyle/>
-          <a:p>
-            <a:pPr indent="0" marL="0">
-              <a:buNone/>
-            </a:pPr>
-            <a:r>
-              <a:rPr lang="en-US" sz="2000" b="1" dirty="0">
-                <a:solidFill>
-                  <a:schemeClr val="tx1"/>
-                </a:solidFill>
-              </a:rPr>
-              <a:t>Votre journal</a:t>
-            </a:r>
-            <a:endParaRPr lang="en-US" sz="2000" dirty="0"/>
-          </a:p>
-        </p:txBody>
-      </p:sp>
-      <p:sp>
-        <p:nvSpPr>
-          <p:cNvPr id="26" name="Text 24"/>
-          <p:cNvSpPr txBox="1"/>
-          <p:nvPr/>
-        </p:nvSpPr>
-        <p:spPr>
-          <a:xfrm>
-            <a:off x="1508760" y="5705856"/>
-            <a:ext cx="9875520" cy="292608"/>
-          </a:xfrm>
-          <a:prstGeom prst="rect">
-            <a:avLst/>
-          </a:prstGeom>
-          <a:noFill/>
-          <a:ln/>
-        </p:spPr>
-        <p:txBody>
-          <a:bodyPr wrap="square" lIns="0" tIns="0" rIns="0" bIns="0" rtlCol="0" anchor="ctr"/>
-          <a:lstStyle/>
-          <a:p>
-            <a:pPr indent="0" marL="0">
-              <a:buNone/>
-            </a:pPr>
-            <a:r>
-              <a:rPr lang="en-US" sz="1400" dirty="0">
-                <a:solidFill>
-                  <a:schemeClr val="tx2"/>
-                </a:solidFill>
-              </a:rPr>
-              <a:t>Un par personne</a:t>
-            </a:r>
-            <a:endParaRPr lang="en-US" sz="1400" dirty="0"/>
+              <a:t>L'IA : POUR VOS MÉDIAS SEULEMENT, JUSQU'À NOUVEL ORDRE</a:t>
+            </a:r>
+            <a:endParaRPr lang="en-US" sz="1300" dirty="0"/>
           </a:p>
         </p:txBody>
       </p:sp>
@@ -8508,8 +7858,8 @@
         </p:nvSpPr>
         <p:spPr>
           <a:xfrm>
-            <a:off x="731520" y="1828800"/>
-            <a:ext cx="10698480" cy="2377440"/>
+            <a:off x="731520" y="411480"/>
+            <a:ext cx="10698480" cy="822960"/>
           </a:xfrm>
           <a:prstGeom prst="rect">
             <a:avLst/>
@@ -8525,49 +7875,124 @@
               <a:buNone/>
             </a:pPr>
             <a:r>
-              <a:rPr lang="en-US" sz="6000" b="1" dirty="0">
+              <a:rPr lang="en-US" sz="3200" b="1" dirty="0">
                 <a:solidFill>
                   <a:schemeClr val="tx1"/>
                 </a:solidFill>
               </a:rPr>
-              <a:t>Pas encore de </a:t>
-            </a:r>
-            <a:pPr algn="l" indent="0" marL="0">
-              <a:buNone/>
-            </a:pPr>
-            <a:r>
-              <a:rPr lang="en-US" sz="6000" b="1" dirty="0">
-                <a:solidFill>
-                  <a:schemeClr val="accent1"/>
-                </a:solidFill>
-              </a:rPr>
-              <a:t>code d'animation</a:t>
-            </a:r>
-            <a:pPr algn="l" indent="0" marL="0">
-              <a:buNone/>
-            </a:pPr>
-            <a:r>
-              <a:rPr lang="en-US" sz="6000" b="1" dirty="0">
+              <a:t>Vos deux prochaines semaines</a:t>
+            </a:r>
+            <a:endParaRPr lang="en-US" sz="3200" dirty="0"/>
+          </a:p>
+        </p:txBody>
+      </p:sp>
+      <p:sp>
+        <p:nvSpPr>
+          <p:cNvPr id="3" name="etape-0"/>
+          <p:cNvSpPr/>
+          <p:nvPr/>
+        </p:nvSpPr>
+        <p:spPr>
+          <a:xfrm>
+            <a:off x="731520" y="1508760"/>
+            <a:ext cx="566928" cy="566928"/>
+          </a:xfrm>
+          <a:prstGeom prst="ellipse">
+            <a:avLst/>
+          </a:prstGeom>
+          <a:solidFill>
+            <a:schemeClr val="accent1"/>
+          </a:solidFill>
+          <a:ln w="12700">
+            <a:solidFill>
+              <a:schemeClr val="accent1"/>
+            </a:solidFill>
+            <a:prstDash val="solid"/>
+          </a:ln>
+        </p:spPr>
+      </p:sp>
+      <p:sp>
+        <p:nvSpPr>
+          <p:cNvPr id="4" name="Text 2"/>
+          <p:cNvSpPr txBox="1"/>
+          <p:nvPr/>
+        </p:nvSpPr>
+        <p:spPr>
+          <a:xfrm>
+            <a:off x="731520" y="1508760"/>
+            <a:ext cx="566928" cy="566928"/>
+          </a:xfrm>
+          <a:prstGeom prst="rect">
+            <a:avLst/>
+          </a:prstGeom>
+          <a:noFill/>
+          <a:ln/>
+        </p:spPr>
+        <p:txBody>
+          <a:bodyPr wrap="square" lIns="0" tIns="0" rIns="0" bIns="0" rtlCol="0" anchor="ctr"/>
+          <a:lstStyle/>
+          <a:p>
+            <a:pPr algn="ctr" indent="0" marL="0">
+              <a:buNone/>
+            </a:pPr>
+            <a:r>
+              <a:rPr lang="en-US" sz="2000" b="1" dirty="0">
+                <a:solidFill>
+                  <a:schemeClr val="bg1"/>
+                </a:solidFill>
+              </a:rPr>
+              <a:t>1</a:t>
+            </a:r>
+            <a:endParaRPr lang="en-US" sz="2000" dirty="0"/>
+          </a:p>
+        </p:txBody>
+      </p:sp>
+      <p:sp>
+        <p:nvSpPr>
+          <p:cNvPr id="5" name="Text 3"/>
+          <p:cNvSpPr txBox="1"/>
+          <p:nvPr/>
+        </p:nvSpPr>
+        <p:spPr>
+          <a:xfrm>
+            <a:off x="1508760" y="1472184"/>
+            <a:ext cx="9875520" cy="365760"/>
+          </a:xfrm>
+          <a:prstGeom prst="rect">
+            <a:avLst/>
+          </a:prstGeom>
+          <a:noFill/>
+          <a:ln/>
+        </p:spPr>
+        <p:txBody>
+          <a:bodyPr wrap="square" lIns="0" tIns="0" rIns="0" bIns="0" rtlCol="0" anchor="ctr"/>
+          <a:lstStyle/>
+          <a:p>
+            <a:pPr indent="0" marL="0">
+              <a:buNone/>
+            </a:pPr>
+            <a:r>
+              <a:rPr lang="en-US" sz="2000" b="1" dirty="0">
                 <a:solidFill>
                   <a:schemeClr val="tx1"/>
                 </a:solidFill>
               </a:rPr>
-              <a:t>.</a:t>
-            </a:r>
-            <a:endParaRPr lang="en-US" sz="6000" dirty="0"/>
-          </a:p>
-        </p:txBody>
-      </p:sp>
-      <p:sp>
-        <p:nvSpPr>
-          <p:cNvPr id="3" name="kicker"/>
-          <p:cNvSpPr txBox="1"/>
-          <p:nvPr/>
-        </p:nvSpPr>
-        <p:spPr>
-          <a:xfrm>
-            <a:off x="731520" y="1463040"/>
-            <a:ext cx="10698480" cy="365760"/>
+              <a:t>Le concept et les chapitres</a:t>
+            </a:r>
+            <a:endParaRPr lang="en-US" sz="2000" dirty="0"/>
+          </a:p>
+        </p:txBody>
+      </p:sp>
+      <p:sp>
+        <p:nvSpPr>
+          <p:cNvPr id="6" name="Text 4"/>
+          <p:cNvSpPr txBox="1"/>
+          <p:nvPr/>
+        </p:nvSpPr>
+        <p:spPr>
+          <a:xfrm>
+            <a:off x="1508760" y="1819656"/>
+            <a:ext cx="9875520" cy="292608"/>
           </a:xfrm>
           <a:prstGeom prst="rect">
             <a:avLst/>
@@ -8583,14 +8008,679 @@
               <a:buNone/>
             </a:pPr>
             <a:r>
-              <a:rPr lang="en-US" sz="1300" spc="400" kern="0" dirty="0">
+              <a:rPr lang="en-US" sz="1400" dirty="0">
                 <a:solidFill>
                   <a:schemeClr val="tx2"/>
                 </a:solidFill>
               </a:rPr>
-              <a:t>D'ICI LE 23 OCTOBRE : LA CONCEPTION</a:t>
-            </a:r>
-            <a:endParaRPr lang="en-US" sz="1300" dirty="0"/>
+              <a:t>Ce que chaque chapitre raconte</a:t>
+            </a:r>
+            <a:endParaRPr lang="en-US" sz="1400" dirty="0"/>
+          </a:p>
+        </p:txBody>
+      </p:sp>
+      <p:sp>
+        <p:nvSpPr>
+          <p:cNvPr id="7" name="etape-1"/>
+          <p:cNvSpPr/>
+          <p:nvPr/>
+        </p:nvSpPr>
+        <p:spPr>
+          <a:xfrm>
+            <a:off x="731520" y="2286000"/>
+            <a:ext cx="566928" cy="566928"/>
+          </a:xfrm>
+          <a:prstGeom prst="ellipse">
+            <a:avLst/>
+          </a:prstGeom>
+          <a:solidFill>
+            <a:schemeClr val="accent1"/>
+          </a:solidFill>
+          <a:ln w="12700">
+            <a:solidFill>
+              <a:schemeClr val="accent1"/>
+            </a:solidFill>
+            <a:prstDash val="solid"/>
+          </a:ln>
+        </p:spPr>
+      </p:sp>
+      <p:sp>
+        <p:nvSpPr>
+          <p:cNvPr id="8" name="Text 6"/>
+          <p:cNvSpPr txBox="1"/>
+          <p:nvPr/>
+        </p:nvSpPr>
+        <p:spPr>
+          <a:xfrm>
+            <a:off x="731520" y="2286000"/>
+            <a:ext cx="566928" cy="566928"/>
+          </a:xfrm>
+          <a:prstGeom prst="rect">
+            <a:avLst/>
+          </a:prstGeom>
+          <a:noFill/>
+          <a:ln/>
+        </p:spPr>
+        <p:txBody>
+          <a:bodyPr wrap="square" lIns="0" tIns="0" rIns="0" bIns="0" rtlCol="0" anchor="ctr"/>
+          <a:lstStyle/>
+          <a:p>
+            <a:pPr algn="ctr" indent="0" marL="0">
+              <a:buNone/>
+            </a:pPr>
+            <a:r>
+              <a:rPr lang="en-US" sz="2000" b="1" dirty="0">
+                <a:solidFill>
+                  <a:schemeClr val="bg1"/>
+                </a:solidFill>
+              </a:rPr>
+              <a:t>2</a:t>
+            </a:r>
+            <a:endParaRPr lang="en-US" sz="2000" dirty="0"/>
+          </a:p>
+        </p:txBody>
+      </p:sp>
+      <p:sp>
+        <p:nvSpPr>
+          <p:cNvPr id="9" name="Text 7"/>
+          <p:cNvSpPr txBox="1"/>
+          <p:nvPr/>
+        </p:nvSpPr>
+        <p:spPr>
+          <a:xfrm>
+            <a:off x="1508760" y="2249424"/>
+            <a:ext cx="9875520" cy="365760"/>
+          </a:xfrm>
+          <a:prstGeom prst="rect">
+            <a:avLst/>
+          </a:prstGeom>
+          <a:noFill/>
+          <a:ln/>
+        </p:spPr>
+        <p:txBody>
+          <a:bodyPr wrap="square" lIns="0" tIns="0" rIns="0" bIns="0" rtlCol="0" anchor="ctr"/>
+          <a:lstStyle/>
+          <a:p>
+            <a:pPr indent="0" marL="0">
+              <a:buNone/>
+            </a:pPr>
+            <a:r>
+              <a:rPr lang="en-US" sz="2000" b="1" dirty="0">
+                <a:solidFill>
+                  <a:schemeClr val="tx1"/>
+                </a:solidFill>
+              </a:rPr>
+              <a:t>Le storyboard dans Figma</a:t>
+            </a:r>
+            <a:endParaRPr lang="en-US" sz="2000" dirty="0"/>
+          </a:p>
+        </p:txBody>
+      </p:sp>
+      <p:sp>
+        <p:nvSpPr>
+          <p:cNvPr id="10" name="Text 8"/>
+          <p:cNvSpPr txBox="1"/>
+          <p:nvPr/>
+        </p:nvSpPr>
+        <p:spPr>
+          <a:xfrm>
+            <a:off x="1508760" y="2596896"/>
+            <a:ext cx="9875520" cy="292608"/>
+          </a:xfrm>
+          <a:prstGeom prst="rect">
+            <a:avLst/>
+          </a:prstGeom>
+          <a:noFill/>
+          <a:ln/>
+        </p:spPr>
+        <p:txBody>
+          <a:bodyPr wrap="square" lIns="0" tIns="0" rIns="0" bIns="0" rtlCol="0" anchor="ctr"/>
+          <a:lstStyle/>
+          <a:p>
+            <a:pPr indent="0" marL="0">
+              <a:buNone/>
+            </a:pPr>
+            <a:r>
+              <a:rPr lang="en-US" sz="1400" dirty="0">
+                <a:solidFill>
+                  <a:schemeClr val="tx2"/>
+                </a:solidFill>
+              </a:rPr>
+              <a:t>Un cadre par chapitre, annoté</a:t>
+            </a:r>
+            <a:endParaRPr lang="en-US" sz="1400" dirty="0"/>
+          </a:p>
+        </p:txBody>
+      </p:sp>
+      <p:sp>
+        <p:nvSpPr>
+          <p:cNvPr id="11" name="etape-2"/>
+          <p:cNvSpPr/>
+          <p:nvPr/>
+        </p:nvSpPr>
+        <p:spPr>
+          <a:xfrm>
+            <a:off x="731520" y="3063240"/>
+            <a:ext cx="566928" cy="566928"/>
+          </a:xfrm>
+          <a:prstGeom prst="ellipse">
+            <a:avLst/>
+          </a:prstGeom>
+          <a:solidFill>
+            <a:schemeClr val="accent1"/>
+          </a:solidFill>
+          <a:ln w="12700">
+            <a:solidFill>
+              <a:schemeClr val="accent1"/>
+            </a:solidFill>
+            <a:prstDash val="solid"/>
+          </a:ln>
+        </p:spPr>
+      </p:sp>
+      <p:sp>
+        <p:nvSpPr>
+          <p:cNvPr id="12" name="Text 10"/>
+          <p:cNvSpPr txBox="1"/>
+          <p:nvPr/>
+        </p:nvSpPr>
+        <p:spPr>
+          <a:xfrm>
+            <a:off x="731520" y="3063240"/>
+            <a:ext cx="566928" cy="566928"/>
+          </a:xfrm>
+          <a:prstGeom prst="rect">
+            <a:avLst/>
+          </a:prstGeom>
+          <a:noFill/>
+          <a:ln/>
+        </p:spPr>
+        <p:txBody>
+          <a:bodyPr wrap="square" lIns="0" tIns="0" rIns="0" bIns="0" rtlCol="0" anchor="ctr"/>
+          <a:lstStyle/>
+          <a:p>
+            <a:pPr algn="ctr" indent="0" marL="0">
+              <a:buNone/>
+            </a:pPr>
+            <a:r>
+              <a:rPr lang="en-US" sz="2000" b="1" dirty="0">
+                <a:solidFill>
+                  <a:schemeClr val="bg1"/>
+                </a:solidFill>
+              </a:rPr>
+              <a:t>3</a:t>
+            </a:r>
+            <a:endParaRPr lang="en-US" sz="2000" dirty="0"/>
+          </a:p>
+        </p:txBody>
+      </p:sp>
+      <p:sp>
+        <p:nvSpPr>
+          <p:cNvPr id="13" name="Text 11"/>
+          <p:cNvSpPr txBox="1"/>
+          <p:nvPr/>
+        </p:nvSpPr>
+        <p:spPr>
+          <a:xfrm>
+            <a:off x="1508760" y="3026664"/>
+            <a:ext cx="9875520" cy="365760"/>
+          </a:xfrm>
+          <a:prstGeom prst="rect">
+            <a:avLst/>
+          </a:prstGeom>
+          <a:noFill/>
+          <a:ln/>
+        </p:spPr>
+        <p:txBody>
+          <a:bodyPr wrap="square" lIns="0" tIns="0" rIns="0" bIns="0" rtlCol="0" anchor="ctr"/>
+          <a:lstStyle/>
+          <a:p>
+            <a:pPr indent="0" marL="0">
+              <a:buNone/>
+            </a:pPr>
+            <a:r>
+              <a:rPr lang="en-US" sz="2000" b="1" dirty="0">
+                <a:solidFill>
+                  <a:schemeClr val="tx1"/>
+                </a:solidFill>
+              </a:rPr>
+              <a:t>La matrice de responsabilités</a:t>
+            </a:r>
+            <a:endParaRPr lang="en-US" sz="2000" dirty="0"/>
+          </a:p>
+        </p:txBody>
+      </p:sp>
+      <p:sp>
+        <p:nvSpPr>
+          <p:cNvPr id="14" name="Text 12"/>
+          <p:cNvSpPr txBox="1"/>
+          <p:nvPr/>
+        </p:nvSpPr>
+        <p:spPr>
+          <a:xfrm>
+            <a:off x="1508760" y="3374136"/>
+            <a:ext cx="9875520" cy="292608"/>
+          </a:xfrm>
+          <a:prstGeom prst="rect">
+            <a:avLst/>
+          </a:prstGeom>
+          <a:noFill/>
+          <a:ln/>
+        </p:spPr>
+        <p:txBody>
+          <a:bodyPr wrap="square" lIns="0" tIns="0" rIns="0" bIns="0" rtlCol="0" anchor="ctr"/>
+          <a:lstStyle/>
+          <a:p>
+            <a:pPr indent="0" marL="0">
+              <a:buNone/>
+            </a:pPr>
+            <a:r>
+              <a:rPr lang="en-US" sz="1400" dirty="0">
+                <a:solidFill>
+                  <a:schemeClr val="tx2"/>
+                </a:solidFill>
+              </a:rPr>
+              <a:t>Qui possède quoi, ensemble</a:t>
+            </a:r>
+            <a:endParaRPr lang="en-US" sz="1400" dirty="0"/>
+          </a:p>
+        </p:txBody>
+      </p:sp>
+      <p:sp>
+        <p:nvSpPr>
+          <p:cNvPr id="15" name="etape-3"/>
+          <p:cNvSpPr/>
+          <p:nvPr/>
+        </p:nvSpPr>
+        <p:spPr>
+          <a:xfrm>
+            <a:off x="731520" y="3840480"/>
+            <a:ext cx="566928" cy="566928"/>
+          </a:xfrm>
+          <a:prstGeom prst="ellipse">
+            <a:avLst/>
+          </a:prstGeom>
+          <a:solidFill>
+            <a:schemeClr val="accent1"/>
+          </a:solidFill>
+          <a:ln w="12700">
+            <a:solidFill>
+              <a:schemeClr val="accent1"/>
+            </a:solidFill>
+            <a:prstDash val="solid"/>
+          </a:ln>
+        </p:spPr>
+      </p:sp>
+      <p:sp>
+        <p:nvSpPr>
+          <p:cNvPr id="16" name="Text 14"/>
+          <p:cNvSpPr txBox="1"/>
+          <p:nvPr/>
+        </p:nvSpPr>
+        <p:spPr>
+          <a:xfrm>
+            <a:off x="731520" y="3840480"/>
+            <a:ext cx="566928" cy="566928"/>
+          </a:xfrm>
+          <a:prstGeom prst="rect">
+            <a:avLst/>
+          </a:prstGeom>
+          <a:noFill/>
+          <a:ln/>
+        </p:spPr>
+        <p:txBody>
+          <a:bodyPr wrap="square" lIns="0" tIns="0" rIns="0" bIns="0" rtlCol="0" anchor="ctr"/>
+          <a:lstStyle/>
+          <a:p>
+            <a:pPr algn="ctr" indent="0" marL="0">
+              <a:buNone/>
+            </a:pPr>
+            <a:r>
+              <a:rPr lang="en-US" sz="2000" b="1" dirty="0">
+                <a:solidFill>
+                  <a:schemeClr val="bg1"/>
+                </a:solidFill>
+              </a:rPr>
+              <a:t>4</a:t>
+            </a:r>
+            <a:endParaRPr lang="en-US" sz="2000" dirty="0"/>
+          </a:p>
+        </p:txBody>
+      </p:sp>
+      <p:sp>
+        <p:nvSpPr>
+          <p:cNvPr id="17" name="Text 15"/>
+          <p:cNvSpPr txBox="1"/>
+          <p:nvPr/>
+        </p:nvSpPr>
+        <p:spPr>
+          <a:xfrm>
+            <a:off x="1508760" y="3803904"/>
+            <a:ext cx="9875520" cy="365760"/>
+          </a:xfrm>
+          <a:prstGeom prst="rect">
+            <a:avLst/>
+          </a:prstGeom>
+          <a:noFill/>
+          <a:ln/>
+        </p:spPr>
+        <p:txBody>
+          <a:bodyPr wrap="square" lIns="0" tIns="0" rIns="0" bIns="0" rtlCol="0" anchor="ctr"/>
+          <a:lstStyle/>
+          <a:p>
+            <a:pPr indent="0" marL="0">
+              <a:buNone/>
+            </a:pPr>
+            <a:r>
+              <a:rPr lang="en-US" sz="2000" b="1" dirty="0">
+                <a:solidFill>
+                  <a:schemeClr val="tx1"/>
+                </a:solidFill>
+              </a:rPr>
+              <a:t>Votre média animable</a:t>
+            </a:r>
+            <a:endParaRPr lang="en-US" sz="2000" dirty="0"/>
+          </a:p>
+        </p:txBody>
+      </p:sp>
+      <p:sp>
+        <p:nvSpPr>
+          <p:cNvPr id="18" name="Text 16"/>
+          <p:cNvSpPr txBox="1"/>
+          <p:nvPr/>
+        </p:nvSpPr>
+        <p:spPr>
+          <a:xfrm>
+            <a:off x="1508760" y="4151376"/>
+            <a:ext cx="9875520" cy="292608"/>
+          </a:xfrm>
+          <a:prstGeom prst="rect">
+            <a:avLst/>
+          </a:prstGeom>
+          <a:noFill/>
+          <a:ln/>
+        </p:spPr>
+        <p:txBody>
+          <a:bodyPr wrap="square" lIns="0" tIns="0" rIns="0" bIns="0" rtlCol="0" anchor="ctr"/>
+          <a:lstStyle/>
+          <a:p>
+            <a:pPr indent="0" marL="0">
+              <a:buNone/>
+            </a:pPr>
+            <a:r>
+              <a:rPr lang="en-US" sz="1400" dirty="0">
+                <a:solidFill>
+                  <a:schemeClr val="tx2"/>
+                </a:solidFill>
+              </a:rPr>
+              <a:t>Calques, spritesheet ou SVG</a:t>
+            </a:r>
+            <a:endParaRPr lang="en-US" sz="1400" dirty="0"/>
+          </a:p>
+        </p:txBody>
+      </p:sp>
+      <p:sp>
+        <p:nvSpPr>
+          <p:cNvPr id="19" name="etape-4"/>
+          <p:cNvSpPr/>
+          <p:nvPr/>
+        </p:nvSpPr>
+        <p:spPr>
+          <a:xfrm>
+            <a:off x="731520" y="4617720"/>
+            <a:ext cx="566928" cy="566928"/>
+          </a:xfrm>
+          <a:prstGeom prst="ellipse">
+            <a:avLst/>
+          </a:prstGeom>
+          <a:solidFill>
+            <a:schemeClr val="accent1"/>
+          </a:solidFill>
+          <a:ln w="12700">
+            <a:solidFill>
+              <a:schemeClr val="accent1"/>
+            </a:solidFill>
+            <a:prstDash val="solid"/>
+          </a:ln>
+        </p:spPr>
+      </p:sp>
+      <p:sp>
+        <p:nvSpPr>
+          <p:cNvPr id="20" name="Text 18"/>
+          <p:cNvSpPr txBox="1"/>
+          <p:nvPr/>
+        </p:nvSpPr>
+        <p:spPr>
+          <a:xfrm>
+            <a:off x="731520" y="4617720"/>
+            <a:ext cx="566928" cy="566928"/>
+          </a:xfrm>
+          <a:prstGeom prst="rect">
+            <a:avLst/>
+          </a:prstGeom>
+          <a:noFill/>
+          <a:ln/>
+        </p:spPr>
+        <p:txBody>
+          <a:bodyPr wrap="square" lIns="0" tIns="0" rIns="0" bIns="0" rtlCol="0" anchor="ctr"/>
+          <a:lstStyle/>
+          <a:p>
+            <a:pPr algn="ctr" indent="0" marL="0">
+              <a:buNone/>
+            </a:pPr>
+            <a:r>
+              <a:rPr lang="en-US" sz="2000" b="1" dirty="0">
+                <a:solidFill>
+                  <a:schemeClr val="bg1"/>
+                </a:solidFill>
+              </a:rPr>
+              <a:t>5</a:t>
+            </a:r>
+            <a:endParaRPr lang="en-US" sz="2000" dirty="0"/>
+          </a:p>
+        </p:txBody>
+      </p:sp>
+      <p:sp>
+        <p:nvSpPr>
+          <p:cNvPr id="21" name="Text 19"/>
+          <p:cNvSpPr txBox="1"/>
+          <p:nvPr/>
+        </p:nvSpPr>
+        <p:spPr>
+          <a:xfrm>
+            <a:off x="1508760" y="4581144"/>
+            <a:ext cx="9875520" cy="365760"/>
+          </a:xfrm>
+          <a:prstGeom prst="rect">
+            <a:avLst/>
+          </a:prstGeom>
+          <a:noFill/>
+          <a:ln/>
+        </p:spPr>
+        <p:txBody>
+          <a:bodyPr wrap="square" lIns="0" tIns="0" rIns="0" bIns="0" rtlCol="0" anchor="ctr"/>
+          <a:lstStyle/>
+          <a:p>
+            <a:pPr indent="0" marL="0">
+              <a:buNone/>
+            </a:pPr>
+            <a:r>
+              <a:rPr lang="en-US" sz="2000" b="1" dirty="0">
+                <a:solidFill>
+                  <a:schemeClr val="tx1"/>
+                </a:solidFill>
+              </a:rPr>
+              <a:t>Le moment dataviz</a:t>
+            </a:r>
+            <a:endParaRPr lang="en-US" sz="2000" dirty="0"/>
+          </a:p>
+        </p:txBody>
+      </p:sp>
+      <p:sp>
+        <p:nvSpPr>
+          <p:cNvPr id="22" name="Text 20"/>
+          <p:cNvSpPr txBox="1"/>
+          <p:nvPr/>
+        </p:nvSpPr>
+        <p:spPr>
+          <a:xfrm>
+            <a:off x="1508760" y="4928616"/>
+            <a:ext cx="9875520" cy="292608"/>
+          </a:xfrm>
+          <a:prstGeom prst="rect">
+            <a:avLst/>
+          </a:prstGeom>
+          <a:noFill/>
+          <a:ln/>
+        </p:spPr>
+        <p:txBody>
+          <a:bodyPr wrap="square" lIns="0" tIns="0" rIns="0" bIns="0" rtlCol="0" anchor="ctr"/>
+          <a:lstStyle/>
+          <a:p>
+            <a:pPr indent="0" marL="0">
+              <a:buNone/>
+            </a:pPr>
+            <a:r>
+              <a:rPr lang="en-US" sz="1400" dirty="0">
+                <a:solidFill>
+                  <a:schemeClr val="tx2"/>
+                </a:solidFill>
+              </a:rPr>
+              <a:t>L'idée et le genre de données</a:t>
+            </a:r>
+            <a:endParaRPr lang="en-US" sz="1400" dirty="0"/>
+          </a:p>
+        </p:txBody>
+      </p:sp>
+      <p:sp>
+        <p:nvSpPr>
+          <p:cNvPr id="23" name="etape-5"/>
+          <p:cNvSpPr/>
+          <p:nvPr/>
+        </p:nvSpPr>
+        <p:spPr>
+          <a:xfrm>
+            <a:off x="731520" y="5394960"/>
+            <a:ext cx="566928" cy="566928"/>
+          </a:xfrm>
+          <a:prstGeom prst="ellipse">
+            <a:avLst/>
+          </a:prstGeom>
+          <a:solidFill>
+            <a:schemeClr val="accent1"/>
+          </a:solidFill>
+          <a:ln w="12700">
+            <a:solidFill>
+              <a:schemeClr val="accent1"/>
+            </a:solidFill>
+            <a:prstDash val="solid"/>
+          </a:ln>
+        </p:spPr>
+      </p:sp>
+      <p:sp>
+        <p:nvSpPr>
+          <p:cNvPr id="24" name="Text 22"/>
+          <p:cNvSpPr txBox="1"/>
+          <p:nvPr/>
+        </p:nvSpPr>
+        <p:spPr>
+          <a:xfrm>
+            <a:off x="731520" y="5394960"/>
+            <a:ext cx="566928" cy="566928"/>
+          </a:xfrm>
+          <a:prstGeom prst="rect">
+            <a:avLst/>
+          </a:prstGeom>
+          <a:noFill/>
+          <a:ln/>
+        </p:spPr>
+        <p:txBody>
+          <a:bodyPr wrap="square" lIns="0" tIns="0" rIns="0" bIns="0" rtlCol="0" anchor="ctr"/>
+          <a:lstStyle/>
+          <a:p>
+            <a:pPr algn="ctr" indent="0" marL="0">
+              <a:buNone/>
+            </a:pPr>
+            <a:r>
+              <a:rPr lang="en-US" sz="2000" b="1" dirty="0">
+                <a:solidFill>
+                  <a:schemeClr val="bg1"/>
+                </a:solidFill>
+              </a:rPr>
+              <a:t>6</a:t>
+            </a:r>
+            <a:endParaRPr lang="en-US" sz="2000" dirty="0"/>
+          </a:p>
+        </p:txBody>
+      </p:sp>
+      <p:sp>
+        <p:nvSpPr>
+          <p:cNvPr id="25" name="Text 23"/>
+          <p:cNvSpPr txBox="1"/>
+          <p:nvPr/>
+        </p:nvSpPr>
+        <p:spPr>
+          <a:xfrm>
+            <a:off x="1508760" y="5358384"/>
+            <a:ext cx="9875520" cy="365760"/>
+          </a:xfrm>
+          <a:prstGeom prst="rect">
+            <a:avLst/>
+          </a:prstGeom>
+          <a:noFill/>
+          <a:ln/>
+        </p:spPr>
+        <p:txBody>
+          <a:bodyPr wrap="square" lIns="0" tIns="0" rIns="0" bIns="0" rtlCol="0" anchor="ctr"/>
+          <a:lstStyle/>
+          <a:p>
+            <a:pPr indent="0" marL="0">
+              <a:buNone/>
+            </a:pPr>
+            <a:r>
+              <a:rPr lang="en-US" sz="2000" b="1" dirty="0">
+                <a:solidFill>
+                  <a:schemeClr val="tx1"/>
+                </a:solidFill>
+              </a:rPr>
+              <a:t>Votre journal</a:t>
+            </a:r>
+            <a:endParaRPr lang="en-US" sz="2000" dirty="0"/>
+          </a:p>
+        </p:txBody>
+      </p:sp>
+      <p:sp>
+        <p:nvSpPr>
+          <p:cNvPr id="26" name="Text 24"/>
+          <p:cNvSpPr txBox="1"/>
+          <p:nvPr/>
+        </p:nvSpPr>
+        <p:spPr>
+          <a:xfrm>
+            <a:off x="1508760" y="5705856"/>
+            <a:ext cx="9875520" cy="292608"/>
+          </a:xfrm>
+          <a:prstGeom prst="rect">
+            <a:avLst/>
+          </a:prstGeom>
+          <a:noFill/>
+          <a:ln/>
+        </p:spPr>
+        <p:txBody>
+          <a:bodyPr wrap="square" lIns="0" tIns="0" rIns="0" bIns="0" rtlCol="0" anchor="ctr"/>
+          <a:lstStyle/>
+          <a:p>
+            <a:pPr indent="0" marL="0">
+              <a:buNone/>
+            </a:pPr>
+            <a:r>
+              <a:rPr lang="en-US" sz="1400" dirty="0">
+                <a:solidFill>
+                  <a:schemeClr val="tx2"/>
+                </a:solidFill>
+              </a:rPr>
+              <a:t>Un par personne</a:t>
+            </a:r>
+            <a:endParaRPr lang="en-US" sz="1400" dirty="0"/>
           </a:p>
         </p:txBody>
       </p:sp>
@@ -8840,8 +8930,8 @@
         </p:nvSpPr>
         <p:spPr>
           <a:xfrm>
-            <a:off x="731520" y="411480"/>
-            <a:ext cx="10698480" cy="822960"/>
+            <a:off x="731520" y="1828800"/>
+            <a:ext cx="10698480" cy="2377440"/>
           </a:xfrm>
           <a:prstGeom prst="rect">
             <a:avLst/>
@@ -8857,25 +8947,36 @@
               <a:buNone/>
             </a:pPr>
             <a:r>
-              <a:rPr lang="en-US" sz="3200" b="1" dirty="0">
+              <a:rPr lang="en-US" sz="6000" b="1" dirty="0">
                 <a:solidFill>
                   <a:schemeClr val="tx1"/>
                 </a:solidFill>
               </a:rPr>
-              <a:t>Remise 1 : </a:t>
+              <a:t>Pas encore de </a:t>
             </a:r>
             <a:pPr algn="l" indent="0" marL="0">
               <a:buNone/>
             </a:pPr>
             <a:r>
-              <a:rPr lang="en-US" sz="3200" b="1" dirty="0">
+              <a:rPr lang="en-US" sz="6000" b="1" dirty="0">
                 <a:solidFill>
                   <a:schemeClr val="accent1"/>
                 </a:solidFill>
               </a:rPr>
-              <a:t>ven. 23 oct.</a:t>
-            </a:r>
-            <a:endParaRPr lang="en-US" sz="3200" dirty="0"/>
+              <a:t>code d'animation</a:t>
+            </a:r>
+            <a:pPr algn="l" indent="0" marL="0">
+              <a:buNone/>
+            </a:pPr>
+            <a:r>
+              <a:rPr lang="en-US" sz="6000" b="1" dirty="0">
+                <a:solidFill>
+                  <a:schemeClr val="tx1"/>
+                </a:solidFill>
+              </a:rPr>
+              <a:t>.</a:t>
+            </a:r>
+            <a:endParaRPr lang="en-US" sz="6000" dirty="0"/>
           </a:p>
         </p:txBody>
       </p:sp>
@@ -8887,7 +8988,7 @@
         </p:nvSpPr>
         <p:spPr>
           <a:xfrm>
-            <a:off x="731520" y="1325880"/>
+            <a:off x="731520" y="1463040"/>
             <a:ext cx="10698480" cy="365760"/>
           </a:xfrm>
           <a:prstGeom prst="rect">
@@ -8909,541 +9010,9 @@
                   <a:schemeClr val="tx2"/>
                 </a:solidFill>
               </a:rPr>
-              <a:t>23 H 59 · PAS DE COURS CE JOUR-LÀ</a:t>
+              <a:t>D'ICI LE 23 OCTOBRE : LA CONCEPTION</a:t>
             </a:r>
             <a:endParaRPr lang="en-US" sz="1300" dirty="0"/>
-          </a:p>
-        </p:txBody>
-      </p:sp>
-      <p:sp>
-        <p:nvSpPr>
-          <p:cNvPr id="4" name="etape-0"/>
-          <p:cNvSpPr/>
-          <p:nvPr/>
-        </p:nvSpPr>
-        <p:spPr>
-          <a:xfrm>
-            <a:off x="731520" y="1874520"/>
-            <a:ext cx="566928" cy="566928"/>
-          </a:xfrm>
-          <a:prstGeom prst="ellipse">
-            <a:avLst/>
-          </a:prstGeom>
-          <a:solidFill>
-            <a:schemeClr val="accent1"/>
-          </a:solidFill>
-          <a:ln w="12700">
-            <a:solidFill>
-              <a:schemeClr val="accent1"/>
-            </a:solidFill>
-            <a:prstDash val="solid"/>
-          </a:ln>
-        </p:spPr>
-      </p:sp>
-      <p:sp>
-        <p:nvSpPr>
-          <p:cNvPr id="5" name="Text 3"/>
-          <p:cNvSpPr txBox="1"/>
-          <p:nvPr/>
-        </p:nvSpPr>
-        <p:spPr>
-          <a:xfrm>
-            <a:off x="731520" y="1874520"/>
-            <a:ext cx="566928" cy="566928"/>
-          </a:xfrm>
-          <a:prstGeom prst="rect">
-            <a:avLst/>
-          </a:prstGeom>
-          <a:noFill/>
-          <a:ln/>
-        </p:spPr>
-        <p:txBody>
-          <a:bodyPr wrap="square" lIns="0" tIns="0" rIns="0" bIns="0" rtlCol="0" anchor="ctr"/>
-          <a:lstStyle/>
-          <a:p>
-            <a:pPr algn="ctr" indent="0" marL="0">
-              <a:buNone/>
-            </a:pPr>
-            <a:r>
-              <a:rPr lang="en-US" sz="2000" b="1" dirty="0">
-                <a:solidFill>
-                  <a:schemeClr val="bg1"/>
-                </a:solidFill>
-              </a:rPr>
-              <a:t>1</a:t>
-            </a:r>
-            <a:endParaRPr lang="en-US" sz="2000" dirty="0"/>
-          </a:p>
-        </p:txBody>
-      </p:sp>
-      <p:sp>
-        <p:nvSpPr>
-          <p:cNvPr id="6" name="Text 4"/>
-          <p:cNvSpPr txBox="1"/>
-          <p:nvPr/>
-        </p:nvSpPr>
-        <p:spPr>
-          <a:xfrm>
-            <a:off x="1508760" y="1837944"/>
-            <a:ext cx="9875520" cy="365760"/>
-          </a:xfrm>
-          <a:prstGeom prst="rect">
-            <a:avLst/>
-          </a:prstGeom>
-          <a:noFill/>
-          <a:ln/>
-        </p:spPr>
-        <p:txBody>
-          <a:bodyPr wrap="square" lIns="0" tIns="0" rIns="0" bIns="0" rtlCol="0" anchor="ctr"/>
-          <a:lstStyle/>
-          <a:p>
-            <a:pPr indent="0" marL="0">
-              <a:buNone/>
-            </a:pPr>
-            <a:r>
-              <a:rPr lang="en-US" sz="2000" b="1" dirty="0">
-                <a:solidFill>
-                  <a:schemeClr val="tx1"/>
-                </a:solidFill>
-              </a:rPr>
-              <a:t>Le dépôt GitHub de l'équipe</a:t>
-            </a:r>
-            <a:endParaRPr lang="en-US" sz="2000" dirty="0"/>
-          </a:p>
-        </p:txBody>
-      </p:sp>
-      <p:sp>
-        <p:nvSpPr>
-          <p:cNvPr id="7" name="Text 5"/>
-          <p:cNvSpPr txBox="1"/>
-          <p:nvPr/>
-        </p:nvSpPr>
-        <p:spPr>
-          <a:xfrm>
-            <a:off x="1508760" y="2185416"/>
-            <a:ext cx="9875520" cy="292608"/>
-          </a:xfrm>
-          <a:prstGeom prst="rect">
-            <a:avLst/>
-          </a:prstGeom>
-          <a:noFill/>
-          <a:ln/>
-        </p:spPr>
-        <p:txBody>
-          <a:bodyPr wrap="square" lIns="0" tIns="0" rIns="0" bIns="0" rtlCol="0" anchor="ctr"/>
-          <a:lstStyle/>
-          <a:p>
-            <a:pPr indent="0" marL="0">
-              <a:buNone/>
-            </a:pPr>
-            <a:r>
-              <a:rPr lang="en-US" sz="1400" dirty="0">
-                <a:solidFill>
-                  <a:schemeClr val="tx2"/>
-                </a:solidFill>
-              </a:rPr>
-              <a:t>Avec marie-michelle-ouellet comme collaboratrice</a:t>
-            </a:r>
-            <a:endParaRPr lang="en-US" sz="1400" dirty="0"/>
-          </a:p>
-        </p:txBody>
-      </p:sp>
-      <p:sp>
-        <p:nvSpPr>
-          <p:cNvPr id="8" name="etape-1"/>
-          <p:cNvSpPr/>
-          <p:nvPr/>
-        </p:nvSpPr>
-        <p:spPr>
-          <a:xfrm>
-            <a:off x="731520" y="2743200"/>
-            <a:ext cx="566928" cy="566928"/>
-          </a:xfrm>
-          <a:prstGeom prst="ellipse">
-            <a:avLst/>
-          </a:prstGeom>
-          <a:solidFill>
-            <a:schemeClr val="accent1"/>
-          </a:solidFill>
-          <a:ln w="12700">
-            <a:solidFill>
-              <a:schemeClr val="accent1"/>
-            </a:solidFill>
-            <a:prstDash val="solid"/>
-          </a:ln>
-        </p:spPr>
-      </p:sp>
-      <p:sp>
-        <p:nvSpPr>
-          <p:cNvPr id="9" name="Text 7"/>
-          <p:cNvSpPr txBox="1"/>
-          <p:nvPr/>
-        </p:nvSpPr>
-        <p:spPr>
-          <a:xfrm>
-            <a:off x="731520" y="2743200"/>
-            <a:ext cx="566928" cy="566928"/>
-          </a:xfrm>
-          <a:prstGeom prst="rect">
-            <a:avLst/>
-          </a:prstGeom>
-          <a:noFill/>
-          <a:ln/>
-        </p:spPr>
-        <p:txBody>
-          <a:bodyPr wrap="square" lIns="0" tIns="0" rIns="0" bIns="0" rtlCol="0" anchor="ctr"/>
-          <a:lstStyle/>
-          <a:p>
-            <a:pPr algn="ctr" indent="0" marL="0">
-              <a:buNone/>
-            </a:pPr>
-            <a:r>
-              <a:rPr lang="en-US" sz="2000" b="1" dirty="0">
-                <a:solidFill>
-                  <a:schemeClr val="bg1"/>
-                </a:solidFill>
-              </a:rPr>
-              <a:t>2</a:t>
-            </a:r>
-            <a:endParaRPr lang="en-US" sz="2000" dirty="0"/>
-          </a:p>
-        </p:txBody>
-      </p:sp>
-      <p:sp>
-        <p:nvSpPr>
-          <p:cNvPr id="10" name="Text 8"/>
-          <p:cNvSpPr txBox="1"/>
-          <p:nvPr/>
-        </p:nvSpPr>
-        <p:spPr>
-          <a:xfrm>
-            <a:off x="1508760" y="2706624"/>
-            <a:ext cx="9875520" cy="365760"/>
-          </a:xfrm>
-          <a:prstGeom prst="rect">
-            <a:avLst/>
-          </a:prstGeom>
-          <a:noFill/>
-          <a:ln/>
-        </p:spPr>
-        <p:txBody>
-          <a:bodyPr wrap="square" lIns="0" tIns="0" rIns="0" bIns="0" rtlCol="0" anchor="ctr"/>
-          <a:lstStyle/>
-          <a:p>
-            <a:pPr indent="0" marL="0">
-              <a:buNone/>
-            </a:pPr>
-            <a:r>
-              <a:rPr lang="en-US" sz="2000" b="1" dirty="0">
-                <a:solidFill>
-                  <a:schemeClr val="tx1"/>
-                </a:solidFill>
-              </a:rPr>
-              <a:t>CAHIER-DE-CHARGES.md complet</a:t>
-            </a:r>
-            <a:endParaRPr lang="en-US" sz="2000" dirty="0"/>
-          </a:p>
-        </p:txBody>
-      </p:sp>
-      <p:sp>
-        <p:nvSpPr>
-          <p:cNvPr id="11" name="Text 9"/>
-          <p:cNvSpPr txBox="1"/>
-          <p:nvPr/>
-        </p:nvSpPr>
-        <p:spPr>
-          <a:xfrm>
-            <a:off x="1508760" y="3054096"/>
-            <a:ext cx="9875520" cy="292608"/>
-          </a:xfrm>
-          <a:prstGeom prst="rect">
-            <a:avLst/>
-          </a:prstGeom>
-          <a:noFill/>
-          <a:ln/>
-        </p:spPr>
-        <p:txBody>
-          <a:bodyPr wrap="square" lIns="0" tIns="0" rIns="0" bIns="0" rtlCol="0" anchor="ctr"/>
-          <a:lstStyle/>
-          <a:p>
-            <a:pPr indent="0" marL="0">
-              <a:buNone/>
-            </a:pPr>
-            <a:r>
-              <a:rPr lang="en-US" sz="1400" dirty="0">
-                <a:solidFill>
-                  <a:schemeClr val="tx2"/>
-                </a:solidFill>
-              </a:rPr>
-              <a:t>À partir du gabarit</a:t>
-            </a:r>
-            <a:endParaRPr lang="en-US" sz="1400" dirty="0"/>
-          </a:p>
-        </p:txBody>
-      </p:sp>
-      <p:sp>
-        <p:nvSpPr>
-          <p:cNvPr id="12" name="etape-2"/>
-          <p:cNvSpPr/>
-          <p:nvPr/>
-        </p:nvSpPr>
-        <p:spPr>
-          <a:xfrm>
-            <a:off x="731520" y="3611880"/>
-            <a:ext cx="566928" cy="566928"/>
-          </a:xfrm>
-          <a:prstGeom prst="ellipse">
-            <a:avLst/>
-          </a:prstGeom>
-          <a:solidFill>
-            <a:schemeClr val="accent1"/>
-          </a:solidFill>
-          <a:ln w="12700">
-            <a:solidFill>
-              <a:schemeClr val="accent1"/>
-            </a:solidFill>
-            <a:prstDash val="solid"/>
-          </a:ln>
-        </p:spPr>
-      </p:sp>
-      <p:sp>
-        <p:nvSpPr>
-          <p:cNvPr id="13" name="Text 11"/>
-          <p:cNvSpPr txBox="1"/>
-          <p:nvPr/>
-        </p:nvSpPr>
-        <p:spPr>
-          <a:xfrm>
-            <a:off x="731520" y="3611880"/>
-            <a:ext cx="566928" cy="566928"/>
-          </a:xfrm>
-          <a:prstGeom prst="rect">
-            <a:avLst/>
-          </a:prstGeom>
-          <a:noFill/>
-          <a:ln/>
-        </p:spPr>
-        <p:txBody>
-          <a:bodyPr wrap="square" lIns="0" tIns="0" rIns="0" bIns="0" rtlCol="0" anchor="ctr"/>
-          <a:lstStyle/>
-          <a:p>
-            <a:pPr algn="ctr" indent="0" marL="0">
-              <a:buNone/>
-            </a:pPr>
-            <a:r>
-              <a:rPr lang="en-US" sz="2000" b="1" dirty="0">
-                <a:solidFill>
-                  <a:schemeClr val="bg1"/>
-                </a:solidFill>
-              </a:rPr>
-              <a:t>3</a:t>
-            </a:r>
-            <a:endParaRPr lang="en-US" sz="2000" dirty="0"/>
-          </a:p>
-        </p:txBody>
-      </p:sp>
-      <p:sp>
-        <p:nvSpPr>
-          <p:cNvPr id="14" name="Text 12"/>
-          <p:cNvSpPr txBox="1"/>
-          <p:nvPr/>
-        </p:nvSpPr>
-        <p:spPr>
-          <a:xfrm>
-            <a:off x="1508760" y="3575304"/>
-            <a:ext cx="9875520" cy="365760"/>
-          </a:xfrm>
-          <a:prstGeom prst="rect">
-            <a:avLst/>
-          </a:prstGeom>
-          <a:noFill/>
-          <a:ln/>
-        </p:spPr>
-        <p:txBody>
-          <a:bodyPr wrap="square" lIns="0" tIns="0" rIns="0" bIns="0" rtlCol="0" anchor="ctr"/>
-          <a:lstStyle/>
-          <a:p>
-            <a:pPr indent="0" marL="0">
-              <a:buNone/>
-            </a:pPr>
-            <a:r>
-              <a:rPr lang="en-US" sz="2000" b="1" dirty="0">
-                <a:solidFill>
-                  <a:schemeClr val="tx1"/>
-                </a:solidFill>
-              </a:rPr>
-              <a:t>Le storyboard dans Figma</a:t>
-            </a:r>
-            <a:endParaRPr lang="en-US" sz="2000" dirty="0"/>
-          </a:p>
-        </p:txBody>
-      </p:sp>
-      <p:sp>
-        <p:nvSpPr>
-          <p:cNvPr id="15" name="Text 13"/>
-          <p:cNvSpPr txBox="1"/>
-          <p:nvPr/>
-        </p:nvSpPr>
-        <p:spPr>
-          <a:xfrm>
-            <a:off x="1508760" y="3922776"/>
-            <a:ext cx="9875520" cy="292608"/>
-          </a:xfrm>
-          <a:prstGeom prst="rect">
-            <a:avLst/>
-          </a:prstGeom>
-          <a:noFill/>
-          <a:ln/>
-        </p:spPr>
-        <p:txBody>
-          <a:bodyPr wrap="square" lIns="0" tIns="0" rIns="0" bIns="0" rtlCol="0" anchor="ctr"/>
-          <a:lstStyle/>
-          <a:p>
-            <a:pPr indent="0" marL="0">
-              <a:buNone/>
-            </a:pPr>
-            <a:r>
-              <a:rPr lang="en-US" sz="1400" dirty="0">
-                <a:solidFill>
-                  <a:schemeClr val="tx2"/>
-                </a:solidFill>
-              </a:rPr>
-              <a:t>Lien dans le README, accès donné</a:t>
-            </a:r>
-            <a:endParaRPr lang="en-US" sz="1400" dirty="0"/>
-          </a:p>
-        </p:txBody>
-      </p:sp>
-      <p:sp>
-        <p:nvSpPr>
-          <p:cNvPr id="16" name="etape-3"/>
-          <p:cNvSpPr/>
-          <p:nvPr/>
-        </p:nvSpPr>
-        <p:spPr>
-          <a:xfrm>
-            <a:off x="731520" y="4480560"/>
-            <a:ext cx="566928" cy="566928"/>
-          </a:xfrm>
-          <a:prstGeom prst="ellipse">
-            <a:avLst/>
-          </a:prstGeom>
-          <a:solidFill>
-            <a:schemeClr val="accent1"/>
-          </a:solidFill>
-          <a:ln w="12700">
-            <a:solidFill>
-              <a:schemeClr val="accent1"/>
-            </a:solidFill>
-            <a:prstDash val="solid"/>
-          </a:ln>
-        </p:spPr>
-      </p:sp>
-      <p:sp>
-        <p:nvSpPr>
-          <p:cNvPr id="17" name="Text 15"/>
-          <p:cNvSpPr txBox="1"/>
-          <p:nvPr/>
-        </p:nvSpPr>
-        <p:spPr>
-          <a:xfrm>
-            <a:off x="731520" y="4480560"/>
-            <a:ext cx="566928" cy="566928"/>
-          </a:xfrm>
-          <a:prstGeom prst="rect">
-            <a:avLst/>
-          </a:prstGeom>
-          <a:noFill/>
-          <a:ln/>
-        </p:spPr>
-        <p:txBody>
-          <a:bodyPr wrap="square" lIns="0" tIns="0" rIns="0" bIns="0" rtlCol="0" anchor="ctr"/>
-          <a:lstStyle/>
-          <a:p>
-            <a:pPr algn="ctr" indent="0" marL="0">
-              <a:buNone/>
-            </a:pPr>
-            <a:r>
-              <a:rPr lang="en-US" sz="2000" b="1" dirty="0">
-                <a:solidFill>
-                  <a:schemeClr val="bg1"/>
-                </a:solidFill>
-              </a:rPr>
-              <a:t>4</a:t>
-            </a:r>
-            <a:endParaRPr lang="en-US" sz="2000" dirty="0"/>
-          </a:p>
-        </p:txBody>
-      </p:sp>
-      <p:sp>
-        <p:nvSpPr>
-          <p:cNvPr id="18" name="Text 16"/>
-          <p:cNvSpPr txBox="1"/>
-          <p:nvPr/>
-        </p:nvSpPr>
-        <p:spPr>
-          <a:xfrm>
-            <a:off x="1508760" y="4443984"/>
-            <a:ext cx="9875520" cy="365760"/>
-          </a:xfrm>
-          <a:prstGeom prst="rect">
-            <a:avLst/>
-          </a:prstGeom>
-          <a:noFill/>
-          <a:ln/>
-        </p:spPr>
-        <p:txBody>
-          <a:bodyPr wrap="square" lIns="0" tIns="0" rIns="0" bIns="0" rtlCol="0" anchor="ctr"/>
-          <a:lstStyle/>
-          <a:p>
-            <a:pPr indent="0" marL="0">
-              <a:buNone/>
-            </a:pPr>
-            <a:r>
-              <a:rPr lang="en-US" sz="2000" b="1" dirty="0">
-                <a:solidFill>
-                  <a:schemeClr val="tx1"/>
-                </a:solidFill>
-              </a:rPr>
-              <a:t>Un journal par personne</a:t>
-            </a:r>
-            <a:endParaRPr lang="en-US" sz="2000" dirty="0"/>
-          </a:p>
-        </p:txBody>
-      </p:sp>
-      <p:sp>
-        <p:nvSpPr>
-          <p:cNvPr id="19" name="Text 17"/>
-          <p:cNvSpPr txBox="1"/>
-          <p:nvPr/>
-        </p:nvSpPr>
-        <p:spPr>
-          <a:xfrm>
-            <a:off x="1508760" y="4791456"/>
-            <a:ext cx="9875520" cy="292608"/>
-          </a:xfrm>
-          <a:prstGeom prst="rect">
-            <a:avLst/>
-          </a:prstGeom>
-          <a:noFill/>
-          <a:ln/>
-        </p:spPr>
-        <p:txBody>
-          <a:bodyPr wrap="square" lIns="0" tIns="0" rIns="0" bIns="0" rtlCol="0" anchor="ctr"/>
-          <a:lstStyle/>
-          <a:p>
-            <a:pPr indent="0" marL="0">
-              <a:buNone/>
-            </a:pPr>
-            <a:r>
-              <a:rPr lang="en-US" sz="1400" dirty="0">
-                <a:solidFill>
-                  <a:schemeClr val="tx2"/>
-                </a:solidFill>
-              </a:rPr>
-              <a:t>Les 5 questions de ce premier bloc</a:t>
-            </a:r>
-            <a:endParaRPr lang="en-US" sz="1400" dirty="0"/>
           </a:p>
         </p:txBody>
       </p:sp>
@@ -9546,21 +9115,21 @@
             <a:r>
               <a:rPr lang="en-US" sz="3200" b="1" dirty="0">
                 <a:solidFill>
+                  <a:schemeClr val="tx1"/>
+                </a:solidFill>
+              </a:rPr>
+              <a:t>Remise 1 : </a:t>
+            </a:r>
+            <a:pPr algn="l" indent="0" marL="0">
+              <a:buNone/>
+            </a:pPr>
+            <a:r>
+              <a:rPr lang="en-US" sz="3200" b="1" dirty="0">
+                <a:solidFill>
                   <a:schemeClr val="accent1"/>
                 </a:solidFill>
               </a:rPr>
-              <a:t>Aujourd'hui</a:t>
-            </a:r>
-            <a:pPr algn="l" indent="0" marL="0">
-              <a:buNone/>
-            </a:pPr>
-            <a:r>
-              <a:rPr lang="en-US" sz="3200" b="1" dirty="0">
-                <a:solidFill>
-                  <a:schemeClr val="tx1"/>
-                </a:solidFill>
-              </a:rPr>
-              <a:t>.</a:t>
+              <a:t>ven. 23 oct.</a:t>
             </a:r>
             <a:endParaRPr lang="en-US" sz="3200" dirty="0"/>
           </a:p>
@@ -9568,13 +9137,49 @@
       </p:sp>
       <p:sp>
         <p:nvSpPr>
-          <p:cNvPr id="3" name="etape-0"/>
+          <p:cNvPr id="3" name="kicker"/>
+          <p:cNvSpPr txBox="1"/>
+          <p:nvPr/>
+        </p:nvSpPr>
+        <p:spPr>
+          <a:xfrm>
+            <a:off x="731520" y="1325880"/>
+            <a:ext cx="10698480" cy="365760"/>
+          </a:xfrm>
+          <a:prstGeom prst="rect">
+            <a:avLst/>
+          </a:prstGeom>
+          <a:noFill/>
+          <a:ln/>
+        </p:spPr>
+        <p:txBody>
+          <a:bodyPr wrap="square" lIns="0" tIns="0" rIns="0" bIns="0" rtlCol="0" anchor="ctr"/>
+          <a:lstStyle/>
+          <a:p>
+            <a:pPr indent="0" marL="0">
+              <a:buNone/>
+            </a:pPr>
+            <a:r>
+              <a:rPr lang="en-US" sz="1300" spc="400" kern="0" dirty="0">
+                <a:solidFill>
+                  <a:schemeClr val="tx2"/>
+                </a:solidFill>
+              </a:rPr>
+              <a:t>23 H 59 · PAS DE COURS CE JOUR-LÀ</a:t>
+            </a:r>
+            <a:endParaRPr lang="en-US" sz="1300" dirty="0"/>
+          </a:p>
+        </p:txBody>
+      </p:sp>
+      <p:sp>
+        <p:nvSpPr>
+          <p:cNvPr id="4" name="etape-0"/>
           <p:cNvSpPr/>
           <p:nvPr/>
         </p:nvSpPr>
         <p:spPr>
           <a:xfrm>
-            <a:off x="731520" y="1737360"/>
+            <a:off x="731520" y="1874520"/>
             <a:ext cx="566928" cy="566928"/>
           </a:xfrm>
           <a:prstGeom prst="ellipse">
@@ -9593,13 +9198,13 @@
       </p:sp>
       <p:sp>
         <p:nvSpPr>
-          <p:cNvPr id="4" name="Text 2"/>
-          <p:cNvSpPr txBox="1"/>
-          <p:nvPr/>
-        </p:nvSpPr>
-        <p:spPr>
-          <a:xfrm>
-            <a:off x="731520" y="1737360"/>
+          <p:cNvPr id="5" name="Text 3"/>
+          <p:cNvSpPr txBox="1"/>
+          <p:nvPr/>
+        </p:nvSpPr>
+        <p:spPr>
+          <a:xfrm>
+            <a:off x="731520" y="1874520"/>
             <a:ext cx="566928" cy="566928"/>
           </a:xfrm>
           <a:prstGeom prst="rect">
@@ -9629,13 +9234,13 @@
       </p:sp>
       <p:sp>
         <p:nvSpPr>
-          <p:cNvPr id="5" name="Text 3"/>
-          <p:cNvSpPr txBox="1"/>
-          <p:nvPr/>
-        </p:nvSpPr>
-        <p:spPr>
-          <a:xfrm>
-            <a:off x="1508760" y="1700784"/>
+          <p:cNvPr id="6" name="Text 4"/>
+          <p:cNvSpPr txBox="1"/>
+          <p:nvPr/>
+        </p:nvSpPr>
+        <p:spPr>
+          <a:xfrm>
+            <a:off x="1508760" y="1837944"/>
             <a:ext cx="9875520" cy="365760"/>
           </a:xfrm>
           <a:prstGeom prst="rect">
@@ -9657,7 +9262,7 @@
                   <a:schemeClr val="tx1"/>
                 </a:solidFill>
               </a:rPr>
-              <a:t>Formez votre équipe</a:t>
+              <a:t>Le dépôt GitHub de l'équipe</a:t>
             </a:r>
             <a:endParaRPr lang="en-US" sz="2000" dirty="0"/>
           </a:p>
@@ -9665,13 +9270,13 @@
       </p:sp>
       <p:sp>
         <p:nvSpPr>
-          <p:cNvPr id="6" name="Text 4"/>
-          <p:cNvSpPr txBox="1"/>
-          <p:nvPr/>
-        </p:nvSpPr>
-        <p:spPr>
-          <a:xfrm>
-            <a:off x="1508760" y="2048256"/>
+          <p:cNvPr id="7" name="Text 5"/>
+          <p:cNvSpPr txBox="1"/>
+          <p:nvPr/>
+        </p:nvSpPr>
+        <p:spPr>
+          <a:xfrm>
+            <a:off x="1508760" y="2185416"/>
             <a:ext cx="9875520" cy="292608"/>
           </a:xfrm>
           <a:prstGeom prst="rect">
@@ -9693,7 +9298,7 @@
                   <a:schemeClr val="tx2"/>
                 </a:solidFill>
               </a:rPr>
-              <a:t>Échangez vos coordonnées pour travailler à distance</a:t>
+              <a:t>Avec marie-michelle-ouellet comme collaboratrice</a:t>
             </a:r>
             <a:endParaRPr lang="en-US" sz="1400" dirty="0"/>
           </a:p>
@@ -9701,13 +9306,13 @@
       </p:sp>
       <p:sp>
         <p:nvSpPr>
-          <p:cNvPr id="7" name="etape-1"/>
+          <p:cNvPr id="8" name="etape-1"/>
           <p:cNvSpPr/>
           <p:nvPr/>
         </p:nvSpPr>
         <p:spPr>
           <a:xfrm>
-            <a:off x="731520" y="2788920"/>
+            <a:off x="731520" y="2743200"/>
             <a:ext cx="566928" cy="566928"/>
           </a:xfrm>
           <a:prstGeom prst="ellipse">
@@ -9726,13 +9331,13 @@
       </p:sp>
       <p:sp>
         <p:nvSpPr>
-          <p:cNvPr id="8" name="Text 6"/>
-          <p:cNvSpPr txBox="1"/>
-          <p:nvPr/>
-        </p:nvSpPr>
-        <p:spPr>
-          <a:xfrm>
-            <a:off x="731520" y="2788920"/>
+          <p:cNvPr id="9" name="Text 7"/>
+          <p:cNvSpPr txBox="1"/>
+          <p:nvPr/>
+        </p:nvSpPr>
+        <p:spPr>
+          <a:xfrm>
+            <a:off x="731520" y="2743200"/>
             <a:ext cx="566928" cy="566928"/>
           </a:xfrm>
           <a:prstGeom prst="rect">
@@ -9762,13 +9367,13 @@
       </p:sp>
       <p:sp>
         <p:nvSpPr>
-          <p:cNvPr id="9" name="Text 7"/>
-          <p:cNvSpPr txBox="1"/>
-          <p:nvPr/>
-        </p:nvSpPr>
-        <p:spPr>
-          <a:xfrm>
-            <a:off x="1508760" y="2752344"/>
+          <p:cNvPr id="10" name="Text 8"/>
+          <p:cNvSpPr txBox="1"/>
+          <p:nvPr/>
+        </p:nvSpPr>
+        <p:spPr>
+          <a:xfrm>
+            <a:off x="1508760" y="2706624"/>
             <a:ext cx="9875520" cy="365760"/>
           </a:xfrm>
           <a:prstGeom prst="rect">
@@ -9790,7 +9395,7 @@
                   <a:schemeClr val="tx1"/>
                 </a:solidFill>
               </a:rPr>
-              <a:t>Choisissez un thème</a:t>
+              <a:t>CAHIER-DE-CHARGES.md complet</a:t>
             </a:r>
             <a:endParaRPr lang="en-US" sz="2000" dirty="0"/>
           </a:p>
@@ -9798,13 +9403,13 @@
       </p:sp>
       <p:sp>
         <p:nvSpPr>
-          <p:cNvPr id="10" name="Text 8"/>
-          <p:cNvSpPr txBox="1"/>
-          <p:nvPr/>
-        </p:nvSpPr>
-        <p:spPr>
-          <a:xfrm>
-            <a:off x="1508760" y="3099816"/>
+          <p:cNvPr id="11" name="Text 9"/>
+          <p:cNvSpPr txBox="1"/>
+          <p:nvPr/>
+        </p:nvSpPr>
+        <p:spPr>
+          <a:xfrm>
+            <a:off x="1508760" y="3054096"/>
             <a:ext cx="9875520" cy="292608"/>
           </a:xfrm>
           <a:prstGeom prst="rect">
@@ -9826,7 +9431,7 @@
                   <a:schemeClr val="tx2"/>
                 </a:solidFill>
               </a:rPr>
-              <a:t>3 idées chacun, puis une seule, en une phrase</a:t>
+              <a:t>À partir du gabarit</a:t>
             </a:r>
             <a:endParaRPr lang="en-US" sz="1400" dirty="0"/>
           </a:p>
@@ -9834,13 +9439,13 @@
       </p:sp>
       <p:sp>
         <p:nvSpPr>
-          <p:cNvPr id="11" name="etape-2"/>
+          <p:cNvPr id="12" name="etape-2"/>
           <p:cNvSpPr/>
           <p:nvPr/>
         </p:nvSpPr>
         <p:spPr>
           <a:xfrm>
-            <a:off x="731520" y="3840480"/>
+            <a:off x="731520" y="3611880"/>
             <a:ext cx="566928" cy="566928"/>
           </a:xfrm>
           <a:prstGeom prst="ellipse">
@@ -9859,13 +9464,13 @@
       </p:sp>
       <p:sp>
         <p:nvSpPr>
-          <p:cNvPr id="12" name="Text 10"/>
-          <p:cNvSpPr txBox="1"/>
-          <p:nvPr/>
-        </p:nvSpPr>
-        <p:spPr>
-          <a:xfrm>
-            <a:off x="731520" y="3840480"/>
+          <p:cNvPr id="13" name="Text 11"/>
+          <p:cNvSpPr txBox="1"/>
+          <p:nvPr/>
+        </p:nvSpPr>
+        <p:spPr>
+          <a:xfrm>
+            <a:off x="731520" y="3611880"/>
             <a:ext cx="566928" cy="566928"/>
           </a:xfrm>
           <a:prstGeom prst="rect">
@@ -9895,13 +9500,13 @@
       </p:sp>
       <p:sp>
         <p:nvSpPr>
-          <p:cNvPr id="13" name="Text 11"/>
-          <p:cNvSpPr txBox="1"/>
-          <p:nvPr/>
-        </p:nvSpPr>
-        <p:spPr>
-          <a:xfrm>
-            <a:off x="1508760" y="3803904"/>
+          <p:cNvPr id="14" name="Text 12"/>
+          <p:cNvSpPr txBox="1"/>
+          <p:nvPr/>
+        </p:nvSpPr>
+        <p:spPr>
+          <a:xfrm>
+            <a:off x="1508760" y="3575304"/>
             <a:ext cx="9875520" cy="365760"/>
           </a:xfrm>
           <a:prstGeom prst="rect">
@@ -9923,7 +9528,7 @@
                   <a:schemeClr val="tx1"/>
                 </a:solidFill>
               </a:rPr>
-              <a:t>Créez le dépôt et copiez le gabarit</a:t>
+              <a:t>Le storyboard dans Figma</a:t>
             </a:r>
             <a:endParaRPr lang="en-US" sz="2000" dirty="0"/>
           </a:p>
@@ -9931,13 +9536,13 @@
       </p:sp>
       <p:sp>
         <p:nvSpPr>
-          <p:cNvPr id="14" name="Text 12"/>
-          <p:cNvSpPr txBox="1"/>
-          <p:nvPr/>
-        </p:nvSpPr>
-        <p:spPr>
-          <a:xfrm>
-            <a:off x="1508760" y="4151376"/>
+          <p:cNvPr id="15" name="Text 13"/>
+          <p:cNvSpPr txBox="1"/>
+          <p:nvPr/>
+        </p:nvSpPr>
+        <p:spPr>
+          <a:xfrm>
+            <a:off x="1508760" y="3922776"/>
             <a:ext cx="9875520" cy="292608"/>
           </a:xfrm>
           <a:prstGeom prst="rect">
@@ -9959,7 +9564,7 @@
                   <a:schemeClr val="tx2"/>
                 </a:solidFill>
               </a:rPr>
-              <a:t>Commencez par la section 1 : le concept</a:t>
+              <a:t>Lien dans le README, accès donné</a:t>
             </a:r>
             <a:endParaRPr lang="en-US" sz="1400" dirty="0"/>
           </a:p>
@@ -9967,14 +9572,75 @@
       </p:sp>
       <p:sp>
         <p:nvSpPr>
-          <p:cNvPr id="15" name="Text 13"/>
-          <p:cNvSpPr txBox="1"/>
-          <p:nvPr/>
-        </p:nvSpPr>
-        <p:spPr>
-          <a:xfrm>
-            <a:off x="731520" y="5120640"/>
-            <a:ext cx="10698480" cy="457200"/>
+          <p:cNvPr id="16" name="etape-3"/>
+          <p:cNvSpPr/>
+          <p:nvPr/>
+        </p:nvSpPr>
+        <p:spPr>
+          <a:xfrm>
+            <a:off x="731520" y="4480560"/>
+            <a:ext cx="566928" cy="566928"/>
+          </a:xfrm>
+          <a:prstGeom prst="ellipse">
+            <a:avLst/>
+          </a:prstGeom>
+          <a:solidFill>
+            <a:schemeClr val="accent1"/>
+          </a:solidFill>
+          <a:ln w="12700">
+            <a:solidFill>
+              <a:schemeClr val="accent1"/>
+            </a:solidFill>
+            <a:prstDash val="solid"/>
+          </a:ln>
+        </p:spPr>
+      </p:sp>
+      <p:sp>
+        <p:nvSpPr>
+          <p:cNvPr id="17" name="Text 15"/>
+          <p:cNvSpPr txBox="1"/>
+          <p:nvPr/>
+        </p:nvSpPr>
+        <p:spPr>
+          <a:xfrm>
+            <a:off x="731520" y="4480560"/>
+            <a:ext cx="566928" cy="566928"/>
+          </a:xfrm>
+          <a:prstGeom prst="rect">
+            <a:avLst/>
+          </a:prstGeom>
+          <a:noFill/>
+          <a:ln/>
+        </p:spPr>
+        <p:txBody>
+          <a:bodyPr wrap="square" lIns="0" tIns="0" rIns="0" bIns="0" rtlCol="0" anchor="ctr"/>
+          <a:lstStyle/>
+          <a:p>
+            <a:pPr algn="ctr" indent="0" marL="0">
+              <a:buNone/>
+            </a:pPr>
+            <a:r>
+              <a:rPr lang="en-US" sz="2000" b="1" dirty="0">
+                <a:solidFill>
+                  <a:schemeClr val="bg1"/>
+                </a:solidFill>
+              </a:rPr>
+              <a:t>4</a:t>
+            </a:r>
+            <a:endParaRPr lang="en-US" sz="2000" dirty="0"/>
+          </a:p>
+        </p:txBody>
+      </p:sp>
+      <p:sp>
+        <p:nvSpPr>
+          <p:cNvPr id="18" name="Text 16"/>
+          <p:cNvSpPr txBox="1"/>
+          <p:nvPr/>
+        </p:nvSpPr>
+        <p:spPr>
+          <a:xfrm>
+            <a:off x="1508760" y="4443984"/>
+            <a:ext cx="9875520" cy="365760"/>
           </a:xfrm>
           <a:prstGeom prst="rect">
             <a:avLst/>
@@ -9992,12 +9658,48 @@
             <a:r>
               <a:rPr lang="en-US" sz="2000" b="1" dirty="0">
                 <a:solidFill>
-                  <a:schemeClr val="accent1"/>
-                </a:solidFill>
-              </a:rPr>
-              <a:t>Faites valider votre thème avant de partir.</a:t>
+                  <a:schemeClr val="tx1"/>
+                </a:solidFill>
+              </a:rPr>
+              <a:t>Un journal par personne</a:t>
             </a:r>
             <a:endParaRPr lang="en-US" sz="2000" dirty="0"/>
+          </a:p>
+        </p:txBody>
+      </p:sp>
+      <p:sp>
+        <p:nvSpPr>
+          <p:cNvPr id="19" name="Text 17"/>
+          <p:cNvSpPr txBox="1"/>
+          <p:nvPr/>
+        </p:nvSpPr>
+        <p:spPr>
+          <a:xfrm>
+            <a:off x="1508760" y="4791456"/>
+            <a:ext cx="9875520" cy="292608"/>
+          </a:xfrm>
+          <a:prstGeom prst="rect">
+            <a:avLst/>
+          </a:prstGeom>
+          <a:noFill/>
+          <a:ln/>
+        </p:spPr>
+        <p:txBody>
+          <a:bodyPr wrap="square" lIns="0" tIns="0" rIns="0" bIns="0" rtlCol="0" anchor="ctr"/>
+          <a:lstStyle/>
+          <a:p>
+            <a:pPr indent="0" marL="0">
+              <a:buNone/>
+            </a:pPr>
+            <a:r>
+              <a:rPr lang="en-US" sz="1400" dirty="0">
+                <a:solidFill>
+                  <a:schemeClr val="tx2"/>
+                </a:solidFill>
+              </a:rPr>
+              <a:t>Les 5 questions de ce premier bloc</a:t>
+            </a:r>
+            <a:endParaRPr lang="en-US" sz="1400" dirty="0"/>
           </a:p>
         </p:txBody>
       </p:sp>
@@ -10041,6 +9743,560 @@
             <a:fld id="{F7021451-1387-4CA6-816F-3879F97B5CBC}" type="slidenum">
               <a:rPr b="0" lang="en-US"/>
               <a:t>21</a:t>
+            </a:fld>
+            <a:endParaRPr lang="en-US"/>
+          </a:p>
+        </p:txBody>
+      </p:sp>
+    </p:spTree>
+  </p:cSld>
+  <p:clrMapOvr>
+    <a:masterClrMapping/>
+  </p:clrMapOvr>
+</p:sld>
+</file>
+
+<file path=ppt/slides/slide22.xml><?xml version="1.0" encoding="utf-8"?>
+<p:sld xmlns:a="http://schemas.openxmlformats.org/drawingml/2006/main" xmlns:r="http://schemas.openxmlformats.org/officeDocument/2006/relationships" xmlns:p="http://schemas.openxmlformats.org/presentationml/2006/main">
+  <p:cSld name="Slide 22">
+    <p:spTree>
+      <p:nvGrpSpPr>
+        <p:cNvPr id="1" name=""/>
+        <p:cNvGrpSpPr/>
+        <p:nvPr/>
+      </p:nvGrpSpPr>
+      <p:grpSpPr>
+        <a:xfrm>
+          <a:off x="0" y="0"/>
+          <a:ext cx="0" cy="0"/>
+          <a:chOff x="0" y="0"/>
+          <a:chExt cx="0" cy="0"/>
+        </a:xfrm>
+      </p:grpSpPr>
+      <p:sp>
+        <p:nvSpPr>
+          <p:cNvPr id="2" name="Text 0"/>
+          <p:cNvSpPr/>
+          <p:nvPr>
+            <p:ph idx="100" type="title" hasCustomPrompt="1"/>
+          </p:nvPr>
+        </p:nvSpPr>
+        <p:spPr>
+          <a:xfrm>
+            <a:off x="731520" y="411480"/>
+            <a:ext cx="10698480" cy="822960"/>
+          </a:xfrm>
+          <a:prstGeom prst="rect">
+            <a:avLst/>
+          </a:prstGeom>
+          <a:noFill/>
+          <a:ln/>
+        </p:spPr>
+        <p:txBody>
+          <a:bodyPr wrap="square" lIns="0" tIns="0" rIns="0" bIns="0" rtlCol="0" anchor="ctr"/>
+          <a:lstStyle/>
+          <a:p>
+            <a:pPr algn="l" indent="0" marL="0">
+              <a:buNone/>
+            </a:pPr>
+            <a:r>
+              <a:rPr lang="en-US" sz="3200" b="1" dirty="0">
+                <a:solidFill>
+                  <a:schemeClr val="accent1"/>
+                </a:solidFill>
+              </a:rPr>
+              <a:t>Aujourd'hui</a:t>
+            </a:r>
+            <a:pPr algn="l" indent="0" marL="0">
+              <a:buNone/>
+            </a:pPr>
+            <a:r>
+              <a:rPr lang="en-US" sz="3200" b="1" dirty="0">
+                <a:solidFill>
+                  <a:schemeClr val="tx1"/>
+                </a:solidFill>
+              </a:rPr>
+              <a:t>.</a:t>
+            </a:r>
+            <a:endParaRPr lang="en-US" sz="3200" dirty="0"/>
+          </a:p>
+        </p:txBody>
+      </p:sp>
+      <p:sp>
+        <p:nvSpPr>
+          <p:cNvPr id="3" name="etape-0"/>
+          <p:cNvSpPr/>
+          <p:nvPr/>
+        </p:nvSpPr>
+        <p:spPr>
+          <a:xfrm>
+            <a:off x="731520" y="1737360"/>
+            <a:ext cx="566928" cy="566928"/>
+          </a:xfrm>
+          <a:prstGeom prst="ellipse">
+            <a:avLst/>
+          </a:prstGeom>
+          <a:solidFill>
+            <a:schemeClr val="accent1"/>
+          </a:solidFill>
+          <a:ln w="12700">
+            <a:solidFill>
+              <a:schemeClr val="accent1"/>
+            </a:solidFill>
+            <a:prstDash val="solid"/>
+          </a:ln>
+        </p:spPr>
+      </p:sp>
+      <p:sp>
+        <p:nvSpPr>
+          <p:cNvPr id="4" name="Text 2"/>
+          <p:cNvSpPr txBox="1"/>
+          <p:nvPr/>
+        </p:nvSpPr>
+        <p:spPr>
+          <a:xfrm>
+            <a:off x="731520" y="1737360"/>
+            <a:ext cx="566928" cy="566928"/>
+          </a:xfrm>
+          <a:prstGeom prst="rect">
+            <a:avLst/>
+          </a:prstGeom>
+          <a:noFill/>
+          <a:ln/>
+        </p:spPr>
+        <p:txBody>
+          <a:bodyPr wrap="square" lIns="0" tIns="0" rIns="0" bIns="0" rtlCol="0" anchor="ctr"/>
+          <a:lstStyle/>
+          <a:p>
+            <a:pPr algn="ctr" indent="0" marL="0">
+              <a:buNone/>
+            </a:pPr>
+            <a:r>
+              <a:rPr lang="en-US" sz="2000" b="1" dirty="0">
+                <a:solidFill>
+                  <a:schemeClr val="bg1"/>
+                </a:solidFill>
+              </a:rPr>
+              <a:t>1</a:t>
+            </a:r>
+            <a:endParaRPr lang="en-US" sz="2000" dirty="0"/>
+          </a:p>
+        </p:txBody>
+      </p:sp>
+      <p:sp>
+        <p:nvSpPr>
+          <p:cNvPr id="5" name="Text 3"/>
+          <p:cNvSpPr txBox="1"/>
+          <p:nvPr/>
+        </p:nvSpPr>
+        <p:spPr>
+          <a:xfrm>
+            <a:off x="1508760" y="1700784"/>
+            <a:ext cx="9875520" cy="365760"/>
+          </a:xfrm>
+          <a:prstGeom prst="rect">
+            <a:avLst/>
+          </a:prstGeom>
+          <a:noFill/>
+          <a:ln/>
+        </p:spPr>
+        <p:txBody>
+          <a:bodyPr wrap="square" lIns="0" tIns="0" rIns="0" bIns="0" rtlCol="0" anchor="ctr"/>
+          <a:lstStyle/>
+          <a:p>
+            <a:pPr indent="0" marL="0">
+              <a:buNone/>
+            </a:pPr>
+            <a:r>
+              <a:rPr lang="en-US" sz="2000" b="1" dirty="0">
+                <a:solidFill>
+                  <a:schemeClr val="tx1"/>
+                </a:solidFill>
+              </a:rPr>
+              <a:t>Formez votre équipe</a:t>
+            </a:r>
+            <a:endParaRPr lang="en-US" sz="2000" dirty="0"/>
+          </a:p>
+        </p:txBody>
+      </p:sp>
+      <p:sp>
+        <p:nvSpPr>
+          <p:cNvPr id="6" name="Text 4"/>
+          <p:cNvSpPr txBox="1"/>
+          <p:nvPr/>
+        </p:nvSpPr>
+        <p:spPr>
+          <a:xfrm>
+            <a:off x="1508760" y="2048256"/>
+            <a:ext cx="9875520" cy="292608"/>
+          </a:xfrm>
+          <a:prstGeom prst="rect">
+            <a:avLst/>
+          </a:prstGeom>
+          <a:noFill/>
+          <a:ln/>
+        </p:spPr>
+        <p:txBody>
+          <a:bodyPr wrap="square" lIns="0" tIns="0" rIns="0" bIns="0" rtlCol="0" anchor="ctr"/>
+          <a:lstStyle/>
+          <a:p>
+            <a:pPr indent="0" marL="0">
+              <a:buNone/>
+            </a:pPr>
+            <a:r>
+              <a:rPr lang="en-US" sz="1400" dirty="0">
+                <a:solidFill>
+                  <a:schemeClr val="tx2"/>
+                </a:solidFill>
+              </a:rPr>
+              <a:t>Échangez vos coordonnées pour travailler à distance</a:t>
+            </a:r>
+            <a:endParaRPr lang="en-US" sz="1400" dirty="0"/>
+          </a:p>
+        </p:txBody>
+      </p:sp>
+      <p:sp>
+        <p:nvSpPr>
+          <p:cNvPr id="7" name="etape-1"/>
+          <p:cNvSpPr/>
+          <p:nvPr/>
+        </p:nvSpPr>
+        <p:spPr>
+          <a:xfrm>
+            <a:off x="731520" y="2788920"/>
+            <a:ext cx="566928" cy="566928"/>
+          </a:xfrm>
+          <a:prstGeom prst="ellipse">
+            <a:avLst/>
+          </a:prstGeom>
+          <a:solidFill>
+            <a:schemeClr val="accent1"/>
+          </a:solidFill>
+          <a:ln w="12700">
+            <a:solidFill>
+              <a:schemeClr val="accent1"/>
+            </a:solidFill>
+            <a:prstDash val="solid"/>
+          </a:ln>
+        </p:spPr>
+      </p:sp>
+      <p:sp>
+        <p:nvSpPr>
+          <p:cNvPr id="8" name="Text 6"/>
+          <p:cNvSpPr txBox="1"/>
+          <p:nvPr/>
+        </p:nvSpPr>
+        <p:spPr>
+          <a:xfrm>
+            <a:off x="731520" y="2788920"/>
+            <a:ext cx="566928" cy="566928"/>
+          </a:xfrm>
+          <a:prstGeom prst="rect">
+            <a:avLst/>
+          </a:prstGeom>
+          <a:noFill/>
+          <a:ln/>
+        </p:spPr>
+        <p:txBody>
+          <a:bodyPr wrap="square" lIns="0" tIns="0" rIns="0" bIns="0" rtlCol="0" anchor="ctr"/>
+          <a:lstStyle/>
+          <a:p>
+            <a:pPr algn="ctr" indent="0" marL="0">
+              <a:buNone/>
+            </a:pPr>
+            <a:r>
+              <a:rPr lang="en-US" sz="2000" b="1" dirty="0">
+                <a:solidFill>
+                  <a:schemeClr val="bg1"/>
+                </a:solidFill>
+              </a:rPr>
+              <a:t>2</a:t>
+            </a:r>
+            <a:endParaRPr lang="en-US" sz="2000" dirty="0"/>
+          </a:p>
+        </p:txBody>
+      </p:sp>
+      <p:sp>
+        <p:nvSpPr>
+          <p:cNvPr id="9" name="Text 7"/>
+          <p:cNvSpPr txBox="1"/>
+          <p:nvPr/>
+        </p:nvSpPr>
+        <p:spPr>
+          <a:xfrm>
+            <a:off x="1508760" y="2752344"/>
+            <a:ext cx="9875520" cy="365760"/>
+          </a:xfrm>
+          <a:prstGeom prst="rect">
+            <a:avLst/>
+          </a:prstGeom>
+          <a:noFill/>
+          <a:ln/>
+        </p:spPr>
+        <p:txBody>
+          <a:bodyPr wrap="square" lIns="0" tIns="0" rIns="0" bIns="0" rtlCol="0" anchor="ctr"/>
+          <a:lstStyle/>
+          <a:p>
+            <a:pPr indent="0" marL="0">
+              <a:buNone/>
+            </a:pPr>
+            <a:r>
+              <a:rPr lang="en-US" sz="2000" b="1" dirty="0">
+                <a:solidFill>
+                  <a:schemeClr val="tx1"/>
+                </a:solidFill>
+              </a:rPr>
+              <a:t>Choisissez un thème</a:t>
+            </a:r>
+            <a:endParaRPr lang="en-US" sz="2000" dirty="0"/>
+          </a:p>
+        </p:txBody>
+      </p:sp>
+      <p:sp>
+        <p:nvSpPr>
+          <p:cNvPr id="10" name="Text 8"/>
+          <p:cNvSpPr txBox="1"/>
+          <p:nvPr/>
+        </p:nvSpPr>
+        <p:spPr>
+          <a:xfrm>
+            <a:off x="1508760" y="3099816"/>
+            <a:ext cx="9875520" cy="292608"/>
+          </a:xfrm>
+          <a:prstGeom prst="rect">
+            <a:avLst/>
+          </a:prstGeom>
+          <a:noFill/>
+          <a:ln/>
+        </p:spPr>
+        <p:txBody>
+          <a:bodyPr wrap="square" lIns="0" tIns="0" rIns="0" bIns="0" rtlCol="0" anchor="ctr"/>
+          <a:lstStyle/>
+          <a:p>
+            <a:pPr indent="0" marL="0">
+              <a:buNone/>
+            </a:pPr>
+            <a:r>
+              <a:rPr lang="en-US" sz="1400" dirty="0">
+                <a:solidFill>
+                  <a:schemeClr val="tx2"/>
+                </a:solidFill>
+              </a:rPr>
+              <a:t>3 idées chacun, puis une seule, en une phrase</a:t>
+            </a:r>
+            <a:endParaRPr lang="en-US" sz="1400" dirty="0"/>
+          </a:p>
+        </p:txBody>
+      </p:sp>
+      <p:sp>
+        <p:nvSpPr>
+          <p:cNvPr id="11" name="etape-2"/>
+          <p:cNvSpPr/>
+          <p:nvPr/>
+        </p:nvSpPr>
+        <p:spPr>
+          <a:xfrm>
+            <a:off x="731520" y="3840480"/>
+            <a:ext cx="566928" cy="566928"/>
+          </a:xfrm>
+          <a:prstGeom prst="ellipse">
+            <a:avLst/>
+          </a:prstGeom>
+          <a:solidFill>
+            <a:schemeClr val="accent1"/>
+          </a:solidFill>
+          <a:ln w="12700">
+            <a:solidFill>
+              <a:schemeClr val="accent1"/>
+            </a:solidFill>
+            <a:prstDash val="solid"/>
+          </a:ln>
+        </p:spPr>
+      </p:sp>
+      <p:sp>
+        <p:nvSpPr>
+          <p:cNvPr id="12" name="Text 10"/>
+          <p:cNvSpPr txBox="1"/>
+          <p:nvPr/>
+        </p:nvSpPr>
+        <p:spPr>
+          <a:xfrm>
+            <a:off x="731520" y="3840480"/>
+            <a:ext cx="566928" cy="566928"/>
+          </a:xfrm>
+          <a:prstGeom prst="rect">
+            <a:avLst/>
+          </a:prstGeom>
+          <a:noFill/>
+          <a:ln/>
+        </p:spPr>
+        <p:txBody>
+          <a:bodyPr wrap="square" lIns="0" tIns="0" rIns="0" bIns="0" rtlCol="0" anchor="ctr"/>
+          <a:lstStyle/>
+          <a:p>
+            <a:pPr algn="ctr" indent="0" marL="0">
+              <a:buNone/>
+            </a:pPr>
+            <a:r>
+              <a:rPr lang="en-US" sz="2000" b="1" dirty="0">
+                <a:solidFill>
+                  <a:schemeClr val="bg1"/>
+                </a:solidFill>
+              </a:rPr>
+              <a:t>3</a:t>
+            </a:r>
+            <a:endParaRPr lang="en-US" sz="2000" dirty="0"/>
+          </a:p>
+        </p:txBody>
+      </p:sp>
+      <p:sp>
+        <p:nvSpPr>
+          <p:cNvPr id="13" name="Text 11"/>
+          <p:cNvSpPr txBox="1"/>
+          <p:nvPr/>
+        </p:nvSpPr>
+        <p:spPr>
+          <a:xfrm>
+            <a:off x="1508760" y="3803904"/>
+            <a:ext cx="9875520" cy="365760"/>
+          </a:xfrm>
+          <a:prstGeom prst="rect">
+            <a:avLst/>
+          </a:prstGeom>
+          <a:noFill/>
+          <a:ln/>
+        </p:spPr>
+        <p:txBody>
+          <a:bodyPr wrap="square" lIns="0" tIns="0" rIns="0" bIns="0" rtlCol="0" anchor="ctr"/>
+          <a:lstStyle/>
+          <a:p>
+            <a:pPr indent="0" marL="0">
+              <a:buNone/>
+            </a:pPr>
+            <a:r>
+              <a:rPr lang="en-US" sz="2000" b="1" dirty="0">
+                <a:solidFill>
+                  <a:schemeClr val="tx1"/>
+                </a:solidFill>
+              </a:rPr>
+              <a:t>Créez le dépôt et copiez le gabarit</a:t>
+            </a:r>
+            <a:endParaRPr lang="en-US" sz="2000" dirty="0"/>
+          </a:p>
+        </p:txBody>
+      </p:sp>
+      <p:sp>
+        <p:nvSpPr>
+          <p:cNvPr id="14" name="Text 12"/>
+          <p:cNvSpPr txBox="1"/>
+          <p:nvPr/>
+        </p:nvSpPr>
+        <p:spPr>
+          <a:xfrm>
+            <a:off x="1508760" y="4151376"/>
+            <a:ext cx="9875520" cy="292608"/>
+          </a:xfrm>
+          <a:prstGeom prst="rect">
+            <a:avLst/>
+          </a:prstGeom>
+          <a:noFill/>
+          <a:ln/>
+        </p:spPr>
+        <p:txBody>
+          <a:bodyPr wrap="square" lIns="0" tIns="0" rIns="0" bIns="0" rtlCol="0" anchor="ctr"/>
+          <a:lstStyle/>
+          <a:p>
+            <a:pPr indent="0" marL="0">
+              <a:buNone/>
+            </a:pPr>
+            <a:r>
+              <a:rPr lang="en-US" sz="1400" dirty="0">
+                <a:solidFill>
+                  <a:schemeClr val="tx2"/>
+                </a:solidFill>
+              </a:rPr>
+              <a:t>Commencez par la section 1 : le concept</a:t>
+            </a:r>
+            <a:endParaRPr lang="en-US" sz="1400" dirty="0"/>
+          </a:p>
+        </p:txBody>
+      </p:sp>
+      <p:sp>
+        <p:nvSpPr>
+          <p:cNvPr id="15" name="Text 13"/>
+          <p:cNvSpPr txBox="1"/>
+          <p:nvPr/>
+        </p:nvSpPr>
+        <p:spPr>
+          <a:xfrm>
+            <a:off x="731520" y="5120640"/>
+            <a:ext cx="10698480" cy="457200"/>
+          </a:xfrm>
+          <a:prstGeom prst="rect">
+            <a:avLst/>
+          </a:prstGeom>
+          <a:noFill/>
+          <a:ln/>
+        </p:spPr>
+        <p:txBody>
+          <a:bodyPr wrap="square" lIns="0" tIns="0" rIns="0" bIns="0" rtlCol="0" anchor="ctr"/>
+          <a:lstStyle/>
+          <a:p>
+            <a:pPr indent="0" marL="0">
+              <a:buNone/>
+            </a:pPr>
+            <a:r>
+              <a:rPr lang="en-US" sz="2000" b="1" dirty="0">
+                <a:solidFill>
+                  <a:schemeClr val="accent1"/>
+                </a:solidFill>
+              </a:rPr>
+              <a:t>Faites valider votre thème avant de partir.</a:t>
+            </a:r>
+            <a:endParaRPr lang="en-US" sz="2000" dirty="0"/>
+          </a:p>
+        </p:txBody>
+      </p:sp>
+      <p:sp>
+        <p:nvSpPr>
+          <p:cNvPr id="25" name="Slide Number Placeholder 0"/>
+          <p:cNvSpPr>
+            <a:spLocks noGrp="1"/>
+          </p:cNvSpPr>
+          <p:nvPr>
+            <p:ph type="sldNum" sz="quarter" idx="4294967295"/>
+          </p:nvPr>
+        </p:nvSpPr>
+        <p:spPr>
+          <a:xfrm>
+            <a:off x="11247120" y="6355080"/>
+            <a:ext cx="548640" cy="274320"/>
+          </a:xfrm>
+          <a:prstGeom prst="rect">
+            <a:avLst/>
+          </a:prstGeom>
+          <a:extLst>
+            <a:ext uri="{C572A759-6A51-4108-AA02-DFA0A04FC94B}">
+              <ma14:wrappingTextBoxFlag xmlns:ma14="http://schemas.microsoft.com/office/mac/drawingml/2011/main" val="0"/>
+            </a:ext>
+          </a:extLst>
+        </p:spPr>
+        <p:txBody>
+          <a:bodyPr/>
+          <a:lstStyle>
+            <a:lvl1pPr>
+              <a:defRPr sz="1000">
+                <a:solidFill>
+                  <a:schemeClr val="tx2"/>
+                </a:solidFill>
+              </a:defRPr>
+            </a:lvl1pPr>
+          </a:lstStyle>
+          <a:p>
+            <a:pPr algn="r"/>
+            <a:fld id="{F7021451-1387-4CA6-816F-3879F97B5CBC}" type="slidenum">
+              <a:rPr b="0" lang="en-US"/>
+              <a:t>22</a:t>
             </a:fld>
             <a:endParaRPr lang="en-US"/>
           </a:p>

</xml_diff>

<commit_message>
liens 404 réparé et retiré lien vers demo rouge
</commit_message>
<xml_diff>
--- a/docs/582-511-web5/assets/documents/Web5_recit-defilant-lancement.pptx
+++ b/docs/582-511-web5/assets/documents/Web5_recit-defilant-lancement.pptx
@@ -128,7 +128,7 @@
   <p:extLst>
     <p:ext uri="{521415D9-36F7-43E2-AB2F-B90AF26B5E84}">
       <p14:sectionLst xmlns:p14="http://schemas.microsoft.com/office/powerpoint/2010/main">
-        <p14:section name="Le projet" id="{37408c3e-cb90-cf10-2823-6d51edb6f835}">
+        <p14:section name="Le projet" id="{21e64a05-8019-426e-52ff-c453f6311aae}">
           <p14:sldIdLst>
             <p14:sldId id="256"/>
             <p14:sldId id="257"/>
@@ -136,7 +136,7 @@
             <p14:sldId id="259"/>
           </p14:sldIdLst>
         </p14:section>
-        <p14:section name="Le produit" id="{537eca6a-df26-dfdb-4a72-67943e1a7666}">
+        <p14:section name="Le produit" id="{aa2afa3e-ff10-ee38-c4ab-7e8a016794d0}">
           <p14:sldIdLst>
             <p14:sldId id="260"/>
             <p14:sldId id="261"/>
@@ -147,14 +147,14 @@
             <p14:sldId id="266"/>
           </p14:sldIdLst>
         </p14:section>
-        <p14:section name="Évaluation" id="{c0a6f961-9075-33c4-0ffc-c0dd0c63ce8d}">
+        <p14:section name="Évaluation" id="{add3077a-407d-35ae-cbde-1c2b2d36dd15}">
           <p14:sldIdLst>
             <p14:sldId id="267"/>
             <p14:sldId id="268"/>
             <p14:sldId id="269"/>
           </p14:sldIdLst>
         </p14:section>
-        <p14:section name="Calendrier" id="{4a371999-4bc9-1a7c-1e6c-b975a3f96467}">
+        <p14:section name="Calendrier" id="{ab82e252-6c23-17d5-e304-24c0be55961e}">
           <p14:sldIdLst>
             <p14:sldId id="270"/>
             <p14:sldId id="271"/>
@@ -162,7 +162,7 @@
             <p14:sldId id="273"/>
           </p14:sldIdLst>
         </p14:section>
-        <p14:section name="À vous" id="{4f22876a-1a4a-8923-388a-ff18ce4c9853}">
+        <p14:section name="À vous" id="{981bed2a-c138-2a9c-9aae-e0dd4b65a666}">
           <p14:sldIdLst>
             <p14:sldId id="274"/>
             <p14:sldId id="275"/>
@@ -1366,7 +1366,7 @@
           <a:p>
             <a:r>
               <a:rPr lang="en-US" dirty="0"/>
-              <a:t>Au portfolio, l'IA était permise, documentée et comprise. Cette fois, on fait un essai : je veux que vous soyez capables de coder par vous-mêmes, et que demander à l'IA ne soit pas un réflexe. Pas de Copilot, pas de ChatGPT ou Claude pour le code, pas d'IA pour le cahier de charges ni le storyboard. Seule exception : générer une image source pour votre média animable, que vous préparez ensuite vous-même. Vous avez la documentation, les notes, la démo, vos collègues et moi. C'est jusqu'à nouvel ordre : si ça change, je vous le dirai.</a:t>
+              <a:t>Au portfolio, l'IA était permise, documentée et comprise. Cette fois, on fait un essai : je veux que vous soyez capables de coder par vous-mêmes, et que demander à l'IA ne soit pas un réflexe. Pas de Copilot, pas de ChatGPT ou Claude pour le code, pas d'IA pour le cahier de charges ni le storyboard. Seule exception : générer une image source pour votre média animable, que vous préparez ensuite vous-même. Vous avez la documentation, les notes, les démos en classe, vos collègues et moi. C'est jusqu'à nouvel ordre : si ça change, je vous le dirai.</a:t>
             </a:r>
             <a:endParaRPr lang="en-US" dirty="0"/>
           </a:p>

</xml_diff>

<commit_message>
ajout info storyboard multicase par chapitre
</commit_message>
<xml_diff>
--- a/docs/582-511-web5/assets/documents/Web5_recit-defilant-lancement.pptx
+++ b/docs/582-511-web5/assets/documents/Web5_recit-defilant-lancement.pptx
@@ -128,7 +128,7 @@
   <p:extLst>
     <p:ext uri="{521415D9-36F7-43E2-AB2F-B90AF26B5E84}">
       <p14:sectionLst xmlns:p14="http://schemas.microsoft.com/office/powerpoint/2010/main">
-        <p14:section name="Le projet" id="{921ce247-43a9-ff2d-1f4c-2c2555d7cd4e}">
+        <p14:section name="Le projet" id="{db65e797-4b9f-f5d2-2f31-283eaec939a4}">
           <p14:sldIdLst>
             <p14:sldId id="256"/>
             <p14:sldId id="257"/>
@@ -136,7 +136,7 @@
             <p14:sldId id="259"/>
           </p14:sldIdLst>
         </p14:section>
-        <p14:section name="Le produit" id="{e86f5758-1a06-57d7-ce1d-b2d05d94df18}">
+        <p14:section name="Le produit" id="{983a934a-8cf5-4512-87e3-c6d691ed3dec}">
           <p14:sldIdLst>
             <p14:sldId id="260"/>
             <p14:sldId id="261"/>
@@ -147,14 +147,14 @@
             <p14:sldId id="266"/>
           </p14:sldIdLst>
         </p14:section>
-        <p14:section name="Évaluation" id="{ec3c7038-8150-24b3-31cb-06621462b8d3}">
+        <p14:section name="Évaluation" id="{45677dfe-bcba-71af-30fd-ae7cc50b7249}">
           <p14:sldIdLst>
             <p14:sldId id="267"/>
             <p14:sldId id="268"/>
             <p14:sldId id="269"/>
           </p14:sldIdLst>
         </p14:section>
-        <p14:section name="Calendrier" id="{c650708c-8405-85cc-1af6-b25f6ce9c75e}">
+        <p14:section name="Calendrier" id="{7f76c450-68ff-aa76-e0b7-c4761932a640}">
           <p14:sldIdLst>
             <p14:sldId id="270"/>
             <p14:sldId id="271"/>
@@ -162,7 +162,7 @@
             <p14:sldId id="273"/>
           </p14:sldIdLst>
         </p14:section>
-        <p14:section name="À vous" id="{661617c9-2d4e-967c-6972-50596802146a}">
+        <p14:section name="À vous" id="{ff5e0cd9-1df0-f58c-41a7-248a63ad77b1}">
           <p14:sldIdLst>
             <p14:sldId id="274"/>
             <p14:sldId id="275"/>
@@ -8146,7 +8146,7 @@
                   <a:schemeClr val="tx2"/>
                 </a:solidFill>
               </a:rPr>
-              <a:t>Un cadre par chapitre, annoté</a:t>
+              <a:t>Des cadres annotés, avec le numéro du chapitre</a:t>
             </a:r>
             <a:endParaRPr lang="en-US" sz="1400" dirty="0"/>
           </a:p>

</xml_diff>

<commit_message>
titre devoirs et mention de critières d'éval
</commit_message>
<xml_diff>
--- a/docs/582-511-web5/assets/documents/Web5_recit-defilant-lancement.pptx
+++ b/docs/582-511-web5/assets/documents/Web5_recit-defilant-lancement.pptx
@@ -128,7 +128,7 @@
   <p:extLst>
     <p:ext uri="{521415D9-36F7-43E2-AB2F-B90AF26B5E84}">
       <p14:sectionLst xmlns:p14="http://schemas.microsoft.com/office/powerpoint/2010/main">
-        <p14:section name="Le projet" id="{db65e797-4b9f-f5d2-2f31-283eaec939a4}">
+        <p14:section name="Le projet" id="{3d476f16-dda7-545b-d7c2-fd55f121cd77}">
           <p14:sldIdLst>
             <p14:sldId id="256"/>
             <p14:sldId id="257"/>
@@ -136,7 +136,7 @@
             <p14:sldId id="259"/>
           </p14:sldIdLst>
         </p14:section>
-        <p14:section name="Le produit" id="{983a934a-8cf5-4512-87e3-c6d691ed3dec}">
+        <p14:section name="Le produit" id="{60cc7774-2ee9-6419-bce4-795f76b8787b}">
           <p14:sldIdLst>
             <p14:sldId id="260"/>
             <p14:sldId id="261"/>
@@ -147,14 +147,14 @@
             <p14:sldId id="266"/>
           </p14:sldIdLst>
         </p14:section>
-        <p14:section name="Évaluation" id="{45677dfe-bcba-71af-30fd-ae7cc50b7249}">
+        <p14:section name="Évaluation" id="{7970e20d-e8ab-c039-b207-c351c432296d}">
           <p14:sldIdLst>
             <p14:sldId id="267"/>
             <p14:sldId id="268"/>
             <p14:sldId id="269"/>
           </p14:sldIdLst>
         </p14:section>
-        <p14:section name="Calendrier" id="{7f76c450-68ff-aa76-e0b7-c4761932a640}">
+        <p14:section name="Calendrier" id="{560b1c26-8798-c0c3-b8be-69bf36e13af0}">
           <p14:sldIdLst>
             <p14:sldId id="270"/>
             <p14:sldId id="271"/>
@@ -162,7 +162,7 @@
             <p14:sldId id="273"/>
           </p14:sldIdLst>
         </p14:section>
-        <p14:section name="À vous" id="{ff5e0cd9-1df0-f58c-41a7-248a63ad77b1}">
+        <p14:section name="À vous" id="{397f0fc6-03da-5411-c9c1-fd640af94add}">
           <p14:sldIdLst>
             <p14:sldId id="274"/>
             <p14:sldId id="275"/>
@@ -926,7 +926,7 @@
           <a:p>
             <a:r>
               <a:rPr lang="en-US" dirty="0"/>
-              <a:t>Les trois volets individuels totalisent 40 %. La grille critériée détaillée sera publiée avant la remise du 23 octobre.</a:t>
+              <a:t>Les trois volets individuels totalisent 40 %.</a:t>
             </a:r>
             <a:endParaRPr lang="en-US" dirty="0"/>
           </a:p>

</xml_diff>